<commit_message>
Deck: move WHAT SURVIVED to slide 9
Slides 8 through 10 built consecutively toward failure, so a live audience sat
in 'this did not work' for three slides before anything turned. The finding now
sits directly after CORE RESULT.

New order: what broke, what survived it, why it broke, the independent check,
the conclusion. The failure analysis reads better after the finding anyway,
because a reader who already knows three categories held up is being told why
the other thirteen did not, rather than being told the whole thing was a loss.

Page markers renumbered.
</commit_message>
<xml_diff>
--- a/Steam_Game_Reception_Validation_Deck.pptx
+++ b/Steam_Game_Reception_Validation_Deck.pptx
@@ -16,9 +16,9 @@
     <p:sldId xmlns:r="http://schemas.openxmlformats.org/officeDocument/2006/relationships" id="261" r:id="R5a3cf8507aed48b2"/>
     <p:sldId xmlns:r="http://schemas.openxmlformats.org/officeDocument/2006/relationships" id="262" r:id="R3fe3f7d202014c93"/>
     <p:sldId xmlns:r="http://schemas.openxmlformats.org/officeDocument/2006/relationships" id="263" r:id="R1ec4223902864652"/>
+    <p:sldId xmlns:ns0="http://schemas.openxmlformats.org/officeDocument/2006/relationships" id="268" ns0:id="rId18"/>
     <p:sldId xmlns:r="http://schemas.openxmlformats.org/officeDocument/2006/relationships" id="267" r:id="Rb7e41c9d02f84a15"/>
     <p:sldId xmlns:r="http://schemas.openxmlformats.org/officeDocument/2006/relationships" id="264" r:id="Ra85f8edc79904ec5"/>
-    <p:sldId xmlns:ns0="http://schemas.openxmlformats.org/officeDocument/2006/relationships" id="268" ns0:id="rId18"/>
     <p:sldId xmlns:r="http://schemas.openxmlformats.org/officeDocument/2006/relationships" id="265" r:id="R5c47a2c827af4b4c"/>
     <p:sldId xmlns:r="http://schemas.openxmlformats.org/officeDocument/2006/relationships" id="266" r:id="R4a95e17721c94fdb"/>
   </p:sldIdLst>
@@ -2787,6 +2787,10 @@
             <a:prstDash val="solid"/>
           </a:ln>
         </p:spPr>
+        <p:txBody xmlns:a="http://schemas.openxmlformats.org/drawingml/2006/main">
+          <a:bodyPr/>
+          <a:p/>
+        </p:txBody>
       </p:sp>
       <p:sp>
         <p:nvSpPr>
@@ -2983,7 +2987,7 @@
                   <a:srgbClr val="2E6F9E"/>
                 </a:solidFill>
               </a:rPr>
-              <a:t>10</a:t>
+              <a:t>11</a:t>
             </a:r>
           </a:p>
         </p:txBody>
@@ -3377,7 +3381,7 @@
                   <a:srgbClr val="2E6F9E"/>
                 </a:solidFill>
               </a:rPr>
-              <a:t>11</a:t>
+              <a:t>09</a:t>
             </a:r>
           </a:p>
         </p:txBody>
@@ -4234,6 +4238,10 @@
             <a:prstDash val="solid"/>
           </a:ln>
         </p:spPr>
+        <p:txBody xmlns:a="http://schemas.openxmlformats.org/drawingml/2006/main">
+          <a:bodyPr/>
+          <a:p/>
+        </p:txBody>
       </p:sp>
       <p:sp>
         <p:nvSpPr>
@@ -4269,6 +4277,10 @@
             <a:prstDash val="solid"/>
           </a:ln>
         </p:spPr>
+        <p:txBody xmlns:a="http://schemas.openxmlformats.org/drawingml/2006/main">
+          <a:bodyPr/>
+          <a:p/>
+        </p:txBody>
       </p:sp>
       <p:sp>
         <p:nvSpPr>
@@ -4454,6 +4466,10 @@
             <a:prstDash val="solid"/>
           </a:ln>
         </p:spPr>
+        <p:txBody xmlns:a="http://schemas.openxmlformats.org/drawingml/2006/main">
+          <a:bodyPr/>
+          <a:p/>
+        </p:txBody>
       </p:sp>
       <p:sp>
         <p:nvSpPr>
@@ -4639,6 +4655,10 @@
             <a:prstDash val="solid"/>
           </a:ln>
         </p:spPr>
+        <p:txBody xmlns:a="http://schemas.openxmlformats.org/drawingml/2006/main">
+          <a:bodyPr/>
+          <a:p/>
+        </p:txBody>
       </p:sp>
       <p:sp>
         <p:nvSpPr>
@@ -4824,6 +4844,10 @@
             <a:prstDash val="solid"/>
           </a:ln>
         </p:spPr>
+        <p:txBody xmlns:a="http://schemas.openxmlformats.org/drawingml/2006/main">
+          <a:bodyPr/>
+          <a:p/>
+        </p:txBody>
       </p:sp>
       <p:sp>
         <p:nvSpPr>
@@ -5009,6 +5033,10 @@
             <a:prstDash val="solid"/>
           </a:ln>
         </p:spPr>
+        <p:txBody xmlns:a="http://schemas.openxmlformats.org/drawingml/2006/main">
+          <a:bodyPr/>
+          <a:p/>
+        </p:txBody>
       </p:sp>
       <p:sp>
         <p:nvSpPr>
@@ -5421,6 +5449,10 @@
             <a:prstDash val="solid"/>
           </a:ln>
         </p:spPr>
+        <p:txBody xmlns:a="http://schemas.openxmlformats.org/drawingml/2006/main">
+          <a:bodyPr/>
+          <a:p/>
+        </p:txBody>
       </p:sp>
       <p:sp>
         <p:nvSpPr>
@@ -5556,6 +5588,10 @@
             <a:prstDash val="solid"/>
           </a:ln>
         </p:spPr>
+        <p:txBody xmlns:a="http://schemas.openxmlformats.org/drawingml/2006/main">
+          <a:bodyPr/>
+          <a:p/>
+        </p:txBody>
       </p:sp>
       <p:sp>
         <p:nvSpPr>
@@ -7024,6 +7060,10 @@
             <a:prstDash val="solid"/>
           </a:ln>
         </p:spPr>
+        <p:txBody xmlns:a="http://schemas.openxmlformats.org/drawingml/2006/main">
+          <a:bodyPr/>
+          <a:p/>
+        </p:txBody>
       </p:sp>
       <p:sp>
         <p:nvSpPr>
@@ -8913,6 +8953,10 @@
             <a:prstDash val="solid"/>
           </a:ln>
         </p:spPr>
+        <p:txBody xmlns:a="http://schemas.openxmlformats.org/drawingml/2006/main">
+          <a:bodyPr/>
+          <a:p/>
+        </p:txBody>
       </p:sp>
       <p:sp>
         <p:nvSpPr>
@@ -9046,6 +9090,10 @@
             <a:prstDash val="solid"/>
           </a:ln>
         </p:spPr>
+        <p:txBody xmlns:a="http://schemas.openxmlformats.org/drawingml/2006/main">
+          <a:bodyPr/>
+          <a:p/>
+        </p:txBody>
       </p:sp>
       <p:sp>
         <p:nvSpPr>
@@ -9744,6 +9792,10 @@
             <a:prstDash val="solid"/>
           </a:ln>
         </p:spPr>
+        <p:txBody xmlns:a="http://schemas.openxmlformats.org/drawingml/2006/main">
+          <a:bodyPr/>
+          <a:p/>
+        </p:txBody>
       </p:sp>
       <p:sp>
         <p:nvSpPr>
@@ -9940,7 +9992,7 @@
                   <a:srgbClr val="2E6F9E"/>
                 </a:solidFill>
               </a:rPr>
-              <a:t>09</a:t>
+              <a:t>10</a:t>
             </a:r>
           </a:p>
         </p:txBody>

</xml_diff>

<commit_message>
Export deck to PDF; narrow slide 8 so it stops contradicting slide 9
Exporting surfaced a real defect. Slide 8 was written when nothing had survived
validation, so its closing bullets made whole-project claims: per-game rates
show only where keywords fired, and no positioning conclusion survives version
1. Moving the finding to slide 9 put a slide presenting a positioning conclusion
directly after a slide denying one exists.

Both bullets are true of the thirteen failed categories and false of the three
that held up. Narrowed to the generated-content rule, which is what slide 8 is
actually about, so the sequence now reads: this rule failed, here is what did
survive, here is why the rest failed.

PDF committed alongside the pptx and linked from the README, since a PDF opens
anywhere and the pptx does not.
</commit_message>
<xml_diff>
--- a/Steam_Game_Reception_Validation_Deck.pptx
+++ b/Steam_Game_Reception_Validation_Deck.pptx
@@ -2348,7 +2348,7 @@
                   <a:srgbClr val="B4553C"/>
                 </a:solidFill>
               </a:rPr>
-              <a:t>INDEPENDENT READING</a:t>
+              <a:t>WHY IT FAILED</a:t>
             </a:r>
           </a:p>
         </p:txBody>
@@ -2398,7 +2398,7 @@
                   <a:srgbClr val="1F3355"/>
                 </a:solidFill>
               </a:rPr>
-              <a:t>A second reader disagreed with me on half of the 30 checked rows</a:t>
+              <a:t>The rules matched subjects, and missed how people actually complain</a:t>
             </a:r>
           </a:p>
         </p:txBody>
@@ -2448,7 +2448,7 @@
                   <a:srgbClr val="2E6F9E"/>
                 </a:solidFill>
               </a:rPr>
-              <a:t>This sets a realistic ceiling: careful readers agree about half the time.</a:t>
+              <a:t>Two separate failures. Only one of them can be fixed by writing better rules.</a:t>
             </a:r>
           </a:p>
         </p:txBody>
@@ -2498,7 +2498,7 @@
                   <a:srgbClr val="2E6F9E"/>
                 </a:solidFill>
               </a:rPr>
-              <a:t>15 / 30</a:t>
+              <a:t>31 of 150</a:t>
             </a:r>
           </a:p>
         </p:txBody>
@@ -2548,7 +2548,7 @@
                   <a:srgbClr val="1F3355"/>
                 </a:solidFill>
               </a:rPr>
-              <a:t>identical labels</a:t>
+              <a:t>reviews matched no rule at all</a:t>
             </a:r>
           </a:p>
         </p:txBody>
@@ -2598,7 +2598,7 @@
                   <a:srgbClr val="B4553C"/>
                 </a:solidFill>
               </a:rPr>
-              <a:t>50.0%</a:t>
+              <a:t>22</a:t>
             </a:r>
           </a:p>
         </p:txBody>
@@ -2648,7 +2648,7 @@
                   <a:srgbClr val="1F3355"/>
                 </a:solidFill>
               </a:rPr>
-              <a:t>of rows disagreed</a:t>
+              <a:t>patterns never once fired correctly</a:t>
             </a:r>
           </a:p>
         </p:txBody>
@@ -2698,7 +2698,7 @@
                   <a:srgbClr val="B4553C"/>
                 </a:solidFill>
               </a:rPr>
-              <a:t>0.588</a:t>
+              <a:t>32 of 44</a:t>
             </a:r>
           </a:p>
         </p:txBody>
@@ -2748,7 +2748,7 @@
                   <a:srgbClr val="1F3355"/>
                 </a:solidFill>
               </a:rPr>
-              <a:t>overlap in labels used</a:t>
+              <a:t>depth complaints the rules missed</a:t>
             </a:r>
           </a:p>
         </p:txBody>
@@ -2837,7 +2837,7 @@
                   <a:srgbClr val="B4553C"/>
                 </a:solidFill>
               </a:rPr>
-              <a:t>Biggest disagreement</a:t>
+              <a:t>The clearest example</a:t>
             </a:r>
           </a:p>
         </p:txBody>
@@ -2887,7 +2887,7 @@
                   <a:srgbClr val="1F3355"/>
                 </a:solidFill>
               </a:rPr>
-              <a:t>Grind complaints: I coded 1 of the 30 rows, the second reader coded 6.</a:t>
+              <a:t>The word “random” fired 11 times and I agreed with none of them. In these reviews it means “randomly generated”, not “unfair”.</a:t>
             </a:r>
           </a:p>
         </p:txBody>
@@ -2937,7 +2937,7 @@
                   <a:srgbClr val="1F3355"/>
                 </a:solidFill>
               </a:rPr>
-              <a:t>Thirty rows, and the second reader is an AI, not a second analyst. Read it as a rough ceiling, not as validation.</a:t>
+              <a:t>Matching the wrong word is fixable. Missing the words people actually use is not.</a:t>
             </a:r>
           </a:p>
         </p:txBody>
@@ -2987,7 +2987,7 @@
                   <a:srgbClr val="2E6F9E"/>
                 </a:solidFill>
               </a:rPr>
-              <a:t>11</a:t>
+              <a:t>10</a:t>
             </a:r>
           </a:p>
         </p:txBody>
@@ -3003,394 +3003,720 @@
 </file>
 
 <file path=ppt/slides/slide11.xml><?xml version="1.0" encoding="utf-8"?>
-<p:sld xmlns:a="http://schemas.openxmlformats.org/drawingml/2006/main" xmlns:p="http://schemas.openxmlformats.org/presentationml/2006/main" xmlns:r="http://schemas.openxmlformats.org/officeDocument/2006/relationships">
+<p:sld xmlns:p="http://schemas.openxmlformats.org/presentationml/2006/main">
   <p:cSld>
+    <p:bg>
+      <p:bgPr>
+        <a:solidFill xmlns:a="http://schemas.openxmlformats.org/drawingml/2006/main">
+          <a:srgbClr val="FFFFFF"/>
+        </a:solidFill>
+      </p:bgPr>
+    </p:bg>
     <p:spTree>
       <p:nvGrpSpPr>
         <p:cNvPr id="1" name=""/>
         <p:cNvGrpSpPr/>
         <p:nvPr/>
       </p:nvGrpSpPr>
-      <p:grpSpPr/>
-      <p:sp>
-        <p:nvSpPr>
-          <p:cNvPr id="2" name="TextBox 1"/>
-          <p:cNvSpPr txBox="1"/>
-          <p:nvPr/>
-        </p:nvSpPr>
-        <p:spPr>
-          <a:xfrm>
-            <a:off x="685800" y="320040"/>
-            <a:ext cx="2852928" cy="228600"/>
-          </a:xfrm>
-          <a:prstGeom prst="rect">
-            <a:avLst/>
-          </a:prstGeom>
-          <a:noFill/>
-        </p:spPr>
-        <p:txBody>
-          <a:bodyPr wrap="square">
-            <a:spAutoFit/>
-          </a:bodyPr>
-          <a:lstStyle/>
-          <a:p>
+      <p:grpSpPr>
+        <a:xfrm xmlns:a="http://schemas.openxmlformats.org/drawingml/2006/main"/>
+      </p:grpSpPr>
+      <p:sp>
+        <p:nvSpPr>
+          <p:cNvPr id="15" name="">
+            <a:extLst xmlns:a="http://schemas.openxmlformats.org/drawingml/2006/main">
+              <a:ext uri="{FF2B5EF4-FFF2-40B4-BE49-F238E27FC236}">
+                <a16:creationId xmlns:a16="http://schemas.microsoft.com/office/drawing/2014/main" id="{B908D76C-BEF7-4CD9-B54E-73A4E0E590E5}"/>
+              </a:ext>
+            </a:extLst>
+          </p:cNvPr>
+          <p:cNvSpPr>
+            <a:spLocks xmlns:a="http://schemas.openxmlformats.org/drawingml/2006/main" noGrp="1"/>
+          </p:cNvSpPr>
+          <p:nvPr/>
+        </p:nvSpPr>
+        <p:spPr>
+          <a:xfrm xmlns:a="http://schemas.openxmlformats.org/drawingml/2006/main">
+            <a:off x="685800" y="323850"/>
+            <a:ext cx="2857500" cy="228600"/>
+          </a:xfrm>
+          <a:prstGeom xmlns:a="http://schemas.openxmlformats.org/drawingml/2006/main" prst="rect">
+            <a:avLst/>
+          </a:prstGeom>
+          <a:noFill xmlns:a="http://schemas.openxmlformats.org/drawingml/2006/main"/>
+          <a:ln xmlns:a="http://schemas.openxmlformats.org/drawingml/2006/main" w="0">
+            <a:noFill/>
+            <a:prstDash val="solid"/>
+          </a:ln>
+        </p:spPr>
+        <p:txBody>
+          <a:bodyPr xmlns:a="http://schemas.openxmlformats.org/drawingml/2006/main" anchor="t"/>
+          <a:lstStyle xmlns:a="http://schemas.openxmlformats.org/drawingml/2006/main"/>
+          <a:p xmlns:a="http://schemas.openxmlformats.org/drawingml/2006/main">
+            <a:pPr algn="l">
+              <a:defRPr sz="1050" b="1">
+                <a:solidFill>
+                  <a:srgbClr val="B4553C"/>
+                </a:solidFill>
+              </a:defRPr>
+            </a:pPr>
             <a:r>
               <a:rPr sz="1050" b="1">
                 <a:solidFill>
                   <a:srgbClr val="B4553C"/>
                 </a:solidFill>
               </a:rPr>
-              <a:t>WHAT SURVIVED</a:t>
-            </a:r>
-          </a:p>
-        </p:txBody>
-      </p:sp>
-      <p:sp>
-        <p:nvSpPr>
-          <p:cNvPr id="3" name="TextBox 2"/>
-          <p:cNvSpPr txBox="1"/>
-          <p:nvPr/>
-        </p:nvSpPr>
-        <p:spPr>
-          <a:xfrm>
-            <a:off x="685800" y="566928"/>
-            <a:ext cx="10817352" cy="548640"/>
-          </a:xfrm>
-          <a:prstGeom prst="rect">
-            <a:avLst/>
-          </a:prstGeom>
-          <a:noFill/>
-        </p:spPr>
-        <p:txBody>
-          <a:bodyPr wrap="square">
-            <a:spAutoFit/>
-          </a:bodyPr>
-          <a:lstStyle/>
-          <a:p>
+              <a:t>INDEPENDENT READING</a:t>
+            </a:r>
+          </a:p>
+        </p:txBody>
+      </p:sp>
+      <p:sp>
+        <p:nvSpPr>
+          <p:cNvPr id="2" name="">
+            <a:extLst xmlns:a="http://schemas.openxmlformats.org/drawingml/2006/main">
+              <a:ext uri="{FF2B5EF4-FFF2-40B4-BE49-F238E27FC236}">
+                <a16:creationId xmlns:a16="http://schemas.microsoft.com/office/drawing/2014/main" id="{A72C9EEB-E4F7-4573-950C-54D39204C468}"/>
+              </a:ext>
+            </a:extLst>
+          </p:cNvPr>
+          <p:cNvSpPr>
+            <a:spLocks xmlns:a="http://schemas.openxmlformats.org/drawingml/2006/main" noGrp="1"/>
+          </p:cNvSpPr>
+          <p:nvPr/>
+        </p:nvSpPr>
+        <p:spPr>
+          <a:xfrm xmlns:a="http://schemas.openxmlformats.org/drawingml/2006/main">
+            <a:off x="685800" y="571500"/>
+            <a:ext cx="10820400" cy="552450"/>
+          </a:xfrm>
+          <a:prstGeom xmlns:a="http://schemas.openxmlformats.org/drawingml/2006/main" prst="rect">
+            <a:avLst/>
+          </a:prstGeom>
+          <a:noFill xmlns:a="http://schemas.openxmlformats.org/drawingml/2006/main"/>
+          <a:ln xmlns:a="http://schemas.openxmlformats.org/drawingml/2006/main" w="0">
+            <a:noFill/>
+            <a:prstDash val="solid"/>
+          </a:ln>
+        </p:spPr>
+        <p:txBody>
+          <a:bodyPr xmlns:a="http://schemas.openxmlformats.org/drawingml/2006/main" anchor="t"/>
+          <a:lstStyle xmlns:a="http://schemas.openxmlformats.org/drawingml/2006/main"/>
+          <a:p xmlns:a="http://schemas.openxmlformats.org/drawingml/2006/main">
+            <a:pPr algn="l">
+              <a:defRPr sz="2850" b="1">
+                <a:solidFill>
+                  <a:srgbClr val="1F3355"/>
+                </a:solidFill>
+              </a:defRPr>
+            </a:pPr>
             <a:r>
               <a:rPr sz="2850" b="1">
                 <a:solidFill>
                   <a:srgbClr val="1F3355"/>
                 </a:solidFill>
               </a:rPr>
-              <a:t>Three categories held up, and they name the problem</a:t>
-            </a:r>
-          </a:p>
-        </p:txBody>
-      </p:sp>
-      <p:sp>
-        <p:nvSpPr>
-          <p:cNvPr id="4" name="TextBox 3"/>
-          <p:cNvSpPr txBox="1"/>
-          <p:nvPr/>
-        </p:nvSpPr>
-        <p:spPr>
-          <a:xfrm>
-            <a:off x="685800" y="1133856"/>
-            <a:ext cx="10817352" cy="365760"/>
-          </a:xfrm>
-          <a:prstGeom prst="rect">
-            <a:avLst/>
-          </a:prstGeom>
-          <a:noFill/>
-        </p:spPr>
-        <p:txBody>
-          <a:bodyPr wrap="square">
-            <a:spAutoFit/>
-          </a:bodyPr>
-          <a:lstStyle/>
-          <a:p>
+              <a:t>A second reader disagreed with me on half of the 30 checked rows</a:t>
+            </a:r>
+          </a:p>
+        </p:txBody>
+      </p:sp>
+      <p:sp>
+        <p:nvSpPr>
+          <p:cNvPr id="3" name="">
+            <a:extLst xmlns:a="http://schemas.openxmlformats.org/drawingml/2006/main">
+              <a:ext uri="{FF2B5EF4-FFF2-40B4-BE49-F238E27FC236}">
+                <a16:creationId xmlns:a16="http://schemas.microsoft.com/office/drawing/2014/main" id="{63A9FB2E-3878-4307-8EC6-2FFEAB6F3218}"/>
+              </a:ext>
+            </a:extLst>
+          </p:cNvPr>
+          <p:cNvSpPr>
+            <a:spLocks xmlns:a="http://schemas.openxmlformats.org/drawingml/2006/main" noGrp="1"/>
+          </p:cNvSpPr>
+          <p:nvPr/>
+        </p:nvSpPr>
+        <p:spPr>
+          <a:xfrm xmlns:a="http://schemas.openxmlformats.org/drawingml/2006/main">
+            <a:off x="685800" y="1133475"/>
+            <a:ext cx="10820400" cy="342900"/>
+          </a:xfrm>
+          <a:prstGeom xmlns:a="http://schemas.openxmlformats.org/drawingml/2006/main" prst="rect">
+            <a:avLst/>
+          </a:prstGeom>
+          <a:noFill xmlns:a="http://schemas.openxmlformats.org/drawingml/2006/main"/>
+          <a:ln xmlns:a="http://schemas.openxmlformats.org/drawingml/2006/main" w="0">
+            <a:noFill/>
+            <a:prstDash val="solid"/>
+          </a:ln>
+        </p:spPr>
+        <p:txBody>
+          <a:bodyPr xmlns:a="http://schemas.openxmlformats.org/drawingml/2006/main" anchor="t"/>
+          <a:lstStyle xmlns:a="http://schemas.openxmlformats.org/drawingml/2006/main"/>
+          <a:p xmlns:a="http://schemas.openxmlformats.org/drawingml/2006/main">
+            <a:pPr algn="l">
+              <a:defRPr sz="1500" b="0">
+                <a:solidFill>
+                  <a:srgbClr val="2E6F9E"/>
+                </a:solidFill>
+              </a:defRPr>
+            </a:pPr>
             <a:r>
               <a:rPr sz="1500" b="0">
                 <a:solidFill>
                   <a:srgbClr val="2E6F9E"/>
                 </a:solidFill>
               </a:rPr>
-              <a:t>Only bugs, grind and interface cleared validation. Unit is the game; rates understate, so read this as a ranking rather than levels.</a:t>
-            </a:r>
-          </a:p>
-        </p:txBody>
-      </p:sp>
-      <p:pic>
-        <p:nvPicPr>
-          <p:cNvPr id="5" name="Picture 4" descr="05b_supported_finding_bare.png"/>
-          <p:cNvPicPr>
-            <a:picLocks noChangeAspect="1"/>
-          </p:cNvPicPr>
-          <p:nvPr/>
-        </p:nvPicPr>
-        <p:blipFill>
-          <a:blip r:embed="rId2"/>
-          <a:stretch>
-            <a:fillRect/>
-          </a:stretch>
-        </p:blipFill>
-        <p:spPr>
-          <a:xfrm>
-            <a:off x="868680" y="1645920"/>
-            <a:ext cx="10469880" cy="4187952"/>
-          </a:xfrm>
-          <a:prstGeom prst="rect">
-            <a:avLst/>
-          </a:prstGeom>
-        </p:spPr>
-      </p:pic>
-      <p:sp>
-        <p:nvSpPr>
-          <p:cNvPr id="6" name="TextBox 5"/>
-          <p:cNvSpPr txBox="1"/>
-          <p:nvPr/>
-        </p:nvSpPr>
-        <p:spPr>
-          <a:xfrm>
-            <a:off x="868680" y="5760720"/>
-            <a:ext cx="3108960" cy="256032"/>
-          </a:xfrm>
-          <a:prstGeom prst="rect">
-            <a:avLst/>
-          </a:prstGeom>
-          <a:noFill/>
-        </p:spPr>
-        <p:txBody>
-          <a:bodyPr wrap="square">
-            <a:spAutoFit/>
-          </a:bodyPr>
-          <a:lstStyle/>
-          <a:p>
-            <a:r>
-              <a:rPr sz="1200" b="1">
+              <a:t>This sets a realistic ceiling: careful readers agree about half the time.</a:t>
+            </a:r>
+          </a:p>
+        </p:txBody>
+      </p:sp>
+      <p:sp>
+        <p:nvSpPr>
+          <p:cNvPr id="4" name="">
+            <a:extLst xmlns:a="http://schemas.openxmlformats.org/drawingml/2006/main">
+              <a:ext uri="{FF2B5EF4-FFF2-40B4-BE49-F238E27FC236}">
+                <a16:creationId xmlns:a16="http://schemas.microsoft.com/office/drawing/2014/main" id="{C20D7528-ABBF-41ED-B61C-11F143F7F575}"/>
+              </a:ext>
+            </a:extLst>
+          </p:cNvPr>
+          <p:cNvSpPr>
+            <a:spLocks xmlns:a="http://schemas.openxmlformats.org/drawingml/2006/main" noGrp="1"/>
+          </p:cNvSpPr>
+          <p:nvPr/>
+        </p:nvSpPr>
+        <p:spPr>
+          <a:xfrm xmlns:a="http://schemas.openxmlformats.org/drawingml/2006/main">
+            <a:off x="819150" y="2076450"/>
+            <a:ext cx="2952750" cy="857250"/>
+          </a:xfrm>
+          <a:prstGeom xmlns:a="http://schemas.openxmlformats.org/drawingml/2006/main" prst="rect">
+            <a:avLst/>
+          </a:prstGeom>
+          <a:noFill xmlns:a="http://schemas.openxmlformats.org/drawingml/2006/main"/>
+          <a:ln xmlns:a="http://schemas.openxmlformats.org/drawingml/2006/main" w="0">
+            <a:noFill/>
+            <a:prstDash val="solid"/>
+          </a:ln>
+        </p:spPr>
+        <p:txBody>
+          <a:bodyPr xmlns:a="http://schemas.openxmlformats.org/drawingml/2006/main" anchor="t"/>
+          <a:lstStyle xmlns:a="http://schemas.openxmlformats.org/drawingml/2006/main"/>
+          <a:p xmlns:a="http://schemas.openxmlformats.org/drawingml/2006/main">
+            <a:pPr algn="ctr">
+              <a:defRPr sz="4950" b="1">
                 <a:solidFill>
                   <a:srgbClr val="2E6F9E"/>
                 </a:solidFill>
-              </a:rPr>
-              <a:t>BUGS</a:t>
-            </a:r>
-          </a:p>
-        </p:txBody>
-      </p:sp>
-      <p:sp>
-        <p:nvSpPr>
-          <p:cNvPr id="7" name="TextBox 6"/>
-          <p:cNvSpPr txBox="1"/>
-          <p:nvPr/>
-        </p:nvSpPr>
-        <p:spPr>
-          <a:xfrm>
-            <a:off x="868680" y="6035040"/>
-            <a:ext cx="3200400" cy="548640"/>
-          </a:xfrm>
-          <a:prstGeom prst="rect">
-            <a:avLst/>
-          </a:prstGeom>
-          <a:noFill/>
-        </p:spPr>
-        <p:txBody>
-          <a:bodyPr wrap="square">
-            <a:spAutoFit/>
-          </a:bodyPr>
-          <a:lstStyle/>
-          <a:p>
+              </a:defRPr>
+            </a:pPr>
+            <a:r>
+              <a:rPr sz="4950" b="1">
+                <a:solidFill>
+                  <a:srgbClr val="2E6F9E"/>
+                </a:solidFill>
+              </a:rPr>
+              <a:t>15 / 30</a:t>
+            </a:r>
+          </a:p>
+        </p:txBody>
+      </p:sp>
+      <p:sp>
+        <p:nvSpPr>
+          <p:cNvPr id="5" name="">
+            <a:extLst xmlns:a="http://schemas.openxmlformats.org/drawingml/2006/main">
+              <a:ext uri="{FF2B5EF4-FFF2-40B4-BE49-F238E27FC236}">
+                <a16:creationId xmlns:a16="http://schemas.microsoft.com/office/drawing/2014/main" id="{5FE5E172-5261-45C7-92E0-B6F858EAD73B}"/>
+              </a:ext>
+            </a:extLst>
+          </p:cNvPr>
+          <p:cNvSpPr>
+            <a:spLocks xmlns:a="http://schemas.openxmlformats.org/drawingml/2006/main" noGrp="1"/>
+          </p:cNvSpPr>
+          <p:nvPr/>
+        </p:nvSpPr>
+        <p:spPr>
+          <a:xfrm xmlns:a="http://schemas.openxmlformats.org/drawingml/2006/main">
+            <a:off x="819150" y="2952750"/>
+            <a:ext cx="2952750" cy="304800"/>
+          </a:xfrm>
+          <a:prstGeom xmlns:a="http://schemas.openxmlformats.org/drawingml/2006/main" prst="rect">
+            <a:avLst/>
+          </a:prstGeom>
+          <a:noFill xmlns:a="http://schemas.openxmlformats.org/drawingml/2006/main"/>
+          <a:ln xmlns:a="http://schemas.openxmlformats.org/drawingml/2006/main" w="0">
+            <a:noFill/>
+            <a:prstDash val="solid"/>
+          </a:ln>
+        </p:spPr>
+        <p:txBody>
+          <a:bodyPr xmlns:a="http://schemas.openxmlformats.org/drawingml/2006/main" anchor="t"/>
+          <a:lstStyle xmlns:a="http://schemas.openxmlformats.org/drawingml/2006/main"/>
+          <a:p xmlns:a="http://schemas.openxmlformats.org/drawingml/2006/main">
+            <a:pPr algn="ctr">
+              <a:defRPr sz="1425" b="1">
+                <a:solidFill>
+                  <a:srgbClr val="1F3355"/>
+                </a:solidFill>
+              </a:defRPr>
+            </a:pPr>
+            <a:r>
+              <a:rPr sz="1425" b="1">
+                <a:solidFill>
+                  <a:srgbClr val="1F3355"/>
+                </a:solidFill>
+              </a:rPr>
+              <a:t>identical labels</a:t>
+            </a:r>
+          </a:p>
+        </p:txBody>
+      </p:sp>
+      <p:sp>
+        <p:nvSpPr>
+          <p:cNvPr id="6" name="">
+            <a:extLst xmlns:a="http://schemas.openxmlformats.org/drawingml/2006/main">
+              <a:ext uri="{FF2B5EF4-FFF2-40B4-BE49-F238E27FC236}">
+                <a16:creationId xmlns:a16="http://schemas.microsoft.com/office/drawing/2014/main" id="{A99E4221-2938-40B6-A6E9-8F555E692B84}"/>
+              </a:ext>
+            </a:extLst>
+          </p:cNvPr>
+          <p:cNvSpPr>
+            <a:spLocks xmlns:a="http://schemas.openxmlformats.org/drawingml/2006/main" noGrp="1"/>
+          </p:cNvSpPr>
+          <p:nvPr/>
+        </p:nvSpPr>
+        <p:spPr>
+          <a:xfrm xmlns:a="http://schemas.openxmlformats.org/drawingml/2006/main">
+            <a:off x="4533900" y="2076450"/>
+            <a:ext cx="2952750" cy="857250"/>
+          </a:xfrm>
+          <a:prstGeom xmlns:a="http://schemas.openxmlformats.org/drawingml/2006/main" prst="rect">
+            <a:avLst/>
+          </a:prstGeom>
+          <a:noFill xmlns:a="http://schemas.openxmlformats.org/drawingml/2006/main"/>
+          <a:ln xmlns:a="http://schemas.openxmlformats.org/drawingml/2006/main" w="0">
+            <a:noFill/>
+            <a:prstDash val="solid"/>
+          </a:ln>
+        </p:spPr>
+        <p:txBody>
+          <a:bodyPr xmlns:a="http://schemas.openxmlformats.org/drawingml/2006/main" anchor="t"/>
+          <a:lstStyle xmlns:a="http://schemas.openxmlformats.org/drawingml/2006/main"/>
+          <a:p xmlns:a="http://schemas.openxmlformats.org/drawingml/2006/main">
+            <a:pPr algn="ctr">
+              <a:defRPr sz="4950" b="1">
+                <a:solidFill>
+                  <a:srgbClr val="B4553C"/>
+                </a:solidFill>
+              </a:defRPr>
+            </a:pPr>
+            <a:r>
+              <a:rPr sz="4950" b="1">
+                <a:solidFill>
+                  <a:srgbClr val="B4553C"/>
+                </a:solidFill>
+              </a:rPr>
+              <a:t>50.0%</a:t>
+            </a:r>
+          </a:p>
+        </p:txBody>
+      </p:sp>
+      <p:sp>
+        <p:nvSpPr>
+          <p:cNvPr id="7" name="">
+            <a:extLst xmlns:a="http://schemas.openxmlformats.org/drawingml/2006/main">
+              <a:ext uri="{FF2B5EF4-FFF2-40B4-BE49-F238E27FC236}">
+                <a16:creationId xmlns:a16="http://schemas.microsoft.com/office/drawing/2014/main" id="{05AAF1A3-E58D-48CD-BADA-6572FEDB74BE}"/>
+              </a:ext>
+            </a:extLst>
+          </p:cNvPr>
+          <p:cNvSpPr>
+            <a:spLocks xmlns:a="http://schemas.openxmlformats.org/drawingml/2006/main" noGrp="1"/>
+          </p:cNvSpPr>
+          <p:nvPr/>
+        </p:nvSpPr>
+        <p:spPr>
+          <a:xfrm xmlns:a="http://schemas.openxmlformats.org/drawingml/2006/main">
+            <a:off x="4533900" y="2952750"/>
+            <a:ext cx="2952750" cy="304800"/>
+          </a:xfrm>
+          <a:prstGeom xmlns:a="http://schemas.openxmlformats.org/drawingml/2006/main" prst="rect">
+            <a:avLst/>
+          </a:prstGeom>
+          <a:noFill xmlns:a="http://schemas.openxmlformats.org/drawingml/2006/main"/>
+          <a:ln xmlns:a="http://schemas.openxmlformats.org/drawingml/2006/main" w="0">
+            <a:noFill/>
+            <a:prstDash val="solid"/>
+          </a:ln>
+        </p:spPr>
+        <p:txBody>
+          <a:bodyPr xmlns:a="http://schemas.openxmlformats.org/drawingml/2006/main" anchor="t"/>
+          <a:lstStyle xmlns:a="http://schemas.openxmlformats.org/drawingml/2006/main"/>
+          <a:p xmlns:a="http://schemas.openxmlformats.org/drawingml/2006/main">
+            <a:pPr algn="ctr">
+              <a:defRPr sz="1425" b="1">
+                <a:solidFill>
+                  <a:srgbClr val="1F3355"/>
+                </a:solidFill>
+              </a:defRPr>
+            </a:pPr>
+            <a:r>
+              <a:rPr sz="1425" b="1">
+                <a:solidFill>
+                  <a:srgbClr val="1F3355"/>
+                </a:solidFill>
+              </a:rPr>
+              <a:t>of rows disagreed</a:t>
+            </a:r>
+          </a:p>
+        </p:txBody>
+      </p:sp>
+      <p:sp>
+        <p:nvSpPr>
+          <p:cNvPr id="8" name="">
+            <a:extLst xmlns:a="http://schemas.openxmlformats.org/drawingml/2006/main">
+              <a:ext uri="{FF2B5EF4-FFF2-40B4-BE49-F238E27FC236}">
+                <a16:creationId xmlns:a16="http://schemas.microsoft.com/office/drawing/2014/main" id="{3BCAD4EE-516A-4E45-9C64-CB3686974C7A}"/>
+              </a:ext>
+            </a:extLst>
+          </p:cNvPr>
+          <p:cNvSpPr>
+            <a:spLocks xmlns:a="http://schemas.openxmlformats.org/drawingml/2006/main" noGrp="1"/>
+          </p:cNvSpPr>
+          <p:nvPr/>
+        </p:nvSpPr>
+        <p:spPr>
+          <a:xfrm xmlns:a="http://schemas.openxmlformats.org/drawingml/2006/main">
+            <a:off x="8248650" y="2076450"/>
+            <a:ext cx="2952750" cy="857250"/>
+          </a:xfrm>
+          <a:prstGeom xmlns:a="http://schemas.openxmlformats.org/drawingml/2006/main" prst="rect">
+            <a:avLst/>
+          </a:prstGeom>
+          <a:noFill xmlns:a="http://schemas.openxmlformats.org/drawingml/2006/main"/>
+          <a:ln xmlns:a="http://schemas.openxmlformats.org/drawingml/2006/main" w="0">
+            <a:noFill/>
+            <a:prstDash val="solid"/>
+          </a:ln>
+        </p:spPr>
+        <p:txBody>
+          <a:bodyPr xmlns:a="http://schemas.openxmlformats.org/drawingml/2006/main" anchor="t"/>
+          <a:lstStyle xmlns:a="http://schemas.openxmlformats.org/drawingml/2006/main"/>
+          <a:p xmlns:a="http://schemas.openxmlformats.org/drawingml/2006/main">
+            <a:pPr algn="ctr">
+              <a:defRPr sz="4950" b="1">
+                <a:solidFill>
+                  <a:srgbClr val="B4553C"/>
+                </a:solidFill>
+              </a:defRPr>
+            </a:pPr>
+            <a:r>
+              <a:rPr sz="4950" b="1">
+                <a:solidFill>
+                  <a:srgbClr val="B4553C"/>
+                </a:solidFill>
+              </a:rPr>
+              <a:t>0.588</a:t>
+            </a:r>
+          </a:p>
+        </p:txBody>
+      </p:sp>
+      <p:sp>
+        <p:nvSpPr>
+          <p:cNvPr id="9" name="">
+            <a:extLst xmlns:a="http://schemas.openxmlformats.org/drawingml/2006/main">
+              <a:ext uri="{FF2B5EF4-FFF2-40B4-BE49-F238E27FC236}">
+                <a16:creationId xmlns:a16="http://schemas.microsoft.com/office/drawing/2014/main" id="{7FB059CE-04A7-4F8A-B226-7D805B128EEE}"/>
+              </a:ext>
+            </a:extLst>
+          </p:cNvPr>
+          <p:cNvSpPr>
+            <a:spLocks xmlns:a="http://schemas.openxmlformats.org/drawingml/2006/main" noGrp="1"/>
+          </p:cNvSpPr>
+          <p:nvPr/>
+        </p:nvSpPr>
+        <p:spPr>
+          <a:xfrm xmlns:a="http://schemas.openxmlformats.org/drawingml/2006/main">
+            <a:off x="8248650" y="2952750"/>
+            <a:ext cx="2952750" cy="304800"/>
+          </a:xfrm>
+          <a:prstGeom xmlns:a="http://schemas.openxmlformats.org/drawingml/2006/main" prst="rect">
+            <a:avLst/>
+          </a:prstGeom>
+          <a:noFill xmlns:a="http://schemas.openxmlformats.org/drawingml/2006/main"/>
+          <a:ln xmlns:a="http://schemas.openxmlformats.org/drawingml/2006/main" w="0">
+            <a:noFill/>
+            <a:prstDash val="solid"/>
+          </a:ln>
+        </p:spPr>
+        <p:txBody>
+          <a:bodyPr xmlns:a="http://schemas.openxmlformats.org/drawingml/2006/main" anchor="t"/>
+          <a:lstStyle xmlns:a="http://schemas.openxmlformats.org/drawingml/2006/main"/>
+          <a:p xmlns:a="http://schemas.openxmlformats.org/drawingml/2006/main">
+            <a:pPr algn="ctr">
+              <a:defRPr sz="1425" b="1">
+                <a:solidFill>
+                  <a:srgbClr val="1F3355"/>
+                </a:solidFill>
+              </a:defRPr>
+            </a:pPr>
+            <a:r>
+              <a:rPr sz="1425" b="1">
+                <a:solidFill>
+                  <a:srgbClr val="1F3355"/>
+                </a:solidFill>
+              </a:rPr>
+              <a:t>overlap in labels used</a:t>
+            </a:r>
+          </a:p>
+        </p:txBody>
+      </p:sp>
+      <p:sp>
+        <p:nvSpPr>
+          <p:cNvPr id="10" name="">
+            <a:extLst xmlns:a="http://schemas.openxmlformats.org/drawingml/2006/main">
+              <a:ext uri="{FF2B5EF4-FFF2-40B4-BE49-F238E27FC236}">
+                <a16:creationId xmlns:a16="http://schemas.microsoft.com/office/drawing/2014/main" id="{7F996775-9E23-44FA-99C8-ACD9FFFC59F2}"/>
+              </a:ext>
+            </a:extLst>
+          </p:cNvPr>
+          <p:cNvSpPr>
+            <a:spLocks xmlns:a="http://schemas.openxmlformats.org/drawingml/2006/main" noGrp="1"/>
+          </p:cNvSpPr>
+          <p:nvPr/>
+        </p:nvSpPr>
+        <p:spPr>
+          <a:xfrm xmlns:a="http://schemas.openxmlformats.org/drawingml/2006/main">
+            <a:off x="838200" y="3886200"/>
+            <a:ext cx="10382250" cy="1257300"/>
+          </a:xfrm>
+          <a:prstGeom xmlns:a="http://schemas.openxmlformats.org/drawingml/2006/main" prst="roundRect">
+            <a:avLst>
+              <a:gd name="adj" fmla="val 9091"/>
+            </a:avLst>
+          </a:prstGeom>
+          <a:solidFill xmlns:a="http://schemas.openxmlformats.org/drawingml/2006/main">
+            <a:srgbClr val="F4E3DD"/>
+          </a:solidFill>
+          <a:ln xmlns:a="http://schemas.openxmlformats.org/drawingml/2006/main" w="9525">
+            <a:solidFill>
+              <a:srgbClr val="F4E3DD"/>
+            </a:solidFill>
+            <a:prstDash val="solid"/>
+          </a:ln>
+        </p:spPr>
+        <p:txBody xmlns:a="http://schemas.openxmlformats.org/drawingml/2006/main">
+          <a:bodyPr/>
+          <a:p/>
+        </p:txBody>
+      </p:sp>
+      <p:sp>
+        <p:nvSpPr>
+          <p:cNvPr id="11" name="">
+            <a:extLst xmlns:a="http://schemas.openxmlformats.org/drawingml/2006/main">
+              <a:ext uri="{FF2B5EF4-FFF2-40B4-BE49-F238E27FC236}">
+                <a16:creationId xmlns:a16="http://schemas.microsoft.com/office/drawing/2014/main" id="{E80D3F1D-D08F-4DAF-89C3-3052BBCAE28B}"/>
+              </a:ext>
+            </a:extLst>
+          </p:cNvPr>
+          <p:cNvSpPr>
+            <a:spLocks xmlns:a="http://schemas.openxmlformats.org/drawingml/2006/main" noGrp="1"/>
+          </p:cNvSpPr>
+          <p:nvPr/>
+        </p:nvSpPr>
+        <p:spPr>
+          <a:xfrm xmlns:a="http://schemas.openxmlformats.org/drawingml/2006/main">
+            <a:off x="1123950" y="4171950"/>
+            <a:ext cx="2571750" cy="266700"/>
+          </a:xfrm>
+          <a:prstGeom xmlns:a="http://schemas.openxmlformats.org/drawingml/2006/main" prst="rect">
+            <a:avLst/>
+          </a:prstGeom>
+          <a:noFill xmlns:a="http://schemas.openxmlformats.org/drawingml/2006/main"/>
+          <a:ln xmlns:a="http://schemas.openxmlformats.org/drawingml/2006/main" w="0">
+            <a:noFill/>
+            <a:prstDash val="solid"/>
+          </a:ln>
+        </p:spPr>
+        <p:txBody>
+          <a:bodyPr xmlns:a="http://schemas.openxmlformats.org/drawingml/2006/main" anchor="t"/>
+          <a:lstStyle xmlns:a="http://schemas.openxmlformats.org/drawingml/2006/main"/>
+          <a:p xmlns:a="http://schemas.openxmlformats.org/drawingml/2006/main">
+            <a:pPr algn="l">
+              <a:defRPr sz="1350" b="1">
+                <a:solidFill>
+                  <a:srgbClr val="B4553C"/>
+                </a:solidFill>
+              </a:defRPr>
+            </a:pPr>
             <a:r>
               <a:rPr sz="1350" b="1">
                 <a:solidFill>
+                  <a:srgbClr val="B4553C"/>
+                </a:solidFill>
+              </a:rPr>
+              <a:t>Biggest disagreement</a:t>
+            </a:r>
+          </a:p>
+        </p:txBody>
+      </p:sp>
+      <p:sp>
+        <p:nvSpPr>
+          <p:cNvPr id="12" name="">
+            <a:extLst xmlns:a="http://schemas.openxmlformats.org/drawingml/2006/main">
+              <a:ext uri="{FF2B5EF4-FFF2-40B4-BE49-F238E27FC236}">
+                <a16:creationId xmlns:a16="http://schemas.microsoft.com/office/drawing/2014/main" id="{266192CF-2380-44EA-8B6C-37E069BBAC36}"/>
+              </a:ext>
+            </a:extLst>
+          </p:cNvPr>
+          <p:cNvSpPr>
+            <a:spLocks xmlns:a="http://schemas.openxmlformats.org/drawingml/2006/main" noGrp="1"/>
+          </p:cNvSpPr>
+          <p:nvPr/>
+        </p:nvSpPr>
+        <p:spPr>
+          <a:xfrm xmlns:a="http://schemas.openxmlformats.org/drawingml/2006/main">
+            <a:off x="3848100" y="4086225"/>
+            <a:ext cx="7010400" cy="628650"/>
+          </a:xfrm>
+          <a:prstGeom xmlns:a="http://schemas.openxmlformats.org/drawingml/2006/main" prst="rect">
+            <a:avLst/>
+          </a:prstGeom>
+          <a:noFill xmlns:a="http://schemas.openxmlformats.org/drawingml/2006/main"/>
+          <a:ln xmlns:a="http://schemas.openxmlformats.org/drawingml/2006/main" w="0">
+            <a:noFill/>
+            <a:prstDash val="solid"/>
+          </a:ln>
+        </p:spPr>
+        <p:txBody>
+          <a:bodyPr xmlns:a="http://schemas.openxmlformats.org/drawingml/2006/main" anchor="t"/>
+          <a:lstStyle xmlns:a="http://schemas.openxmlformats.org/drawingml/2006/main"/>
+          <a:p xmlns:a="http://schemas.openxmlformats.org/drawingml/2006/main">
+            <a:pPr algn="l">
+              <a:defRPr sz="1725" b="1">
+                <a:solidFill>
                   <a:srgbClr val="1F3355"/>
                 </a:solidFill>
-              </a:rPr>
-              <a:t>Flat across all four shelves (1.2x).</a:t>
-            </a:r>
-          </a:p>
-          <a:p>
-            <a:r>
-              <a:rPr sz="1350" b="1">
+              </a:defRPr>
+            </a:pPr>
+            <a:r>
+              <a:rPr sz="1725" b="1">
                 <a:solidFill>
                   <a:srgbClr val="1F3355"/>
                 </a:solidFill>
               </a:rPr>
-              <a:t>The price of entry, not a lever.</a:t>
-            </a:r>
-          </a:p>
-        </p:txBody>
-      </p:sp>
-      <p:sp>
-        <p:nvSpPr>
-          <p:cNvPr id="8" name="TextBox 7"/>
-          <p:cNvSpPr txBox="1"/>
-          <p:nvPr/>
-        </p:nvSpPr>
-        <p:spPr>
-          <a:xfrm>
-            <a:off x="4480560" y="5760720"/>
-            <a:ext cx="3108960" cy="256032"/>
-          </a:xfrm>
-          <a:prstGeom prst="rect">
-            <a:avLst/>
-          </a:prstGeom>
-          <a:noFill/>
-        </p:spPr>
-        <p:txBody>
-          <a:bodyPr wrap="square">
-            <a:spAutoFit/>
-          </a:bodyPr>
-          <a:lstStyle/>
-          <a:p>
-            <a:r>
-              <a:rPr sz="1200" b="1">
-                <a:solidFill>
-                  <a:srgbClr val="B4553C"/>
-                </a:solidFill>
-              </a:rPr>
-              <a:t>GRIND</a:t>
-            </a:r>
-          </a:p>
-        </p:txBody>
-      </p:sp>
-      <p:sp>
-        <p:nvSpPr>
-          <p:cNvPr id="9" name="TextBox 8"/>
-          <p:cNvSpPr txBox="1"/>
-          <p:nvPr/>
-        </p:nvSpPr>
-        <p:spPr>
-          <a:xfrm>
-            <a:off x="4480560" y="6035040"/>
-            <a:ext cx="3200400" cy="548640"/>
-          </a:xfrm>
-          <a:prstGeom prst="rect">
-            <a:avLst/>
-          </a:prstGeom>
-          <a:noFill/>
-        </p:spPr>
-        <p:txBody>
-          <a:bodyPr wrap="square">
-            <a:spAutoFit/>
-          </a:bodyPr>
-          <a:lstStyle/>
-          <a:p>
-            <a:r>
-              <a:rPr sz="1350" b="1">
+              <a:t>Grind complaints: I coded 1 of the 30 rows, the second reader coded 6.</a:t>
+            </a:r>
+          </a:p>
+        </p:txBody>
+      </p:sp>
+      <p:sp>
+        <p:nvSpPr>
+          <p:cNvPr id="13" name="">
+            <a:extLst xmlns:a="http://schemas.openxmlformats.org/drawingml/2006/main">
+              <a:ext uri="{FF2B5EF4-FFF2-40B4-BE49-F238E27FC236}">
+                <a16:creationId xmlns:a16="http://schemas.microsoft.com/office/drawing/2014/main" id="{82FF8426-CE28-4860-AFCD-FA2E667472EF}"/>
+              </a:ext>
+            </a:extLst>
+          </p:cNvPr>
+          <p:cNvSpPr>
+            <a:spLocks xmlns:a="http://schemas.openxmlformats.org/drawingml/2006/main" noGrp="1"/>
+          </p:cNvSpPr>
+          <p:nvPr/>
+        </p:nvSpPr>
+        <p:spPr>
+          <a:xfrm xmlns:a="http://schemas.openxmlformats.org/drawingml/2006/main">
+            <a:off x="1143000" y="5543550"/>
+            <a:ext cx="9906000" cy="457200"/>
+          </a:xfrm>
+          <a:prstGeom xmlns:a="http://schemas.openxmlformats.org/drawingml/2006/main" prst="rect">
+            <a:avLst/>
+          </a:prstGeom>
+          <a:noFill xmlns:a="http://schemas.openxmlformats.org/drawingml/2006/main"/>
+          <a:ln xmlns:a="http://schemas.openxmlformats.org/drawingml/2006/main" w="0">
+            <a:noFill/>
+            <a:prstDash val="solid"/>
+          </a:ln>
+        </p:spPr>
+        <p:txBody>
+          <a:bodyPr xmlns:a="http://schemas.openxmlformats.org/drawingml/2006/main" anchor="t"/>
+          <a:lstStyle xmlns:a="http://schemas.openxmlformats.org/drawingml/2006/main"/>
+          <a:p xmlns:a="http://schemas.openxmlformats.org/drawingml/2006/main">
+            <a:pPr algn="l">
+              <a:defRPr sz="1500" b="1">
                 <a:solidFill>
                   <a:srgbClr val="1F3355"/>
                 </a:solidFill>
-              </a:rPr>
-              <a:t>3.0x worse in life sims (27% vs 9%).</a:t>
-            </a:r>
-          </a:p>
-        </p:txBody>
-      </p:sp>
-      <p:sp>
-        <p:nvSpPr>
-          <p:cNvPr id="10" name="TextBox 9"/>
-          <p:cNvSpPr txBox="1"/>
-          <p:nvPr/>
-        </p:nvSpPr>
-        <p:spPr>
-          <a:xfrm>
-            <a:off x="8092440" y="5760720"/>
-            <a:ext cx="3108960" cy="256032"/>
-          </a:xfrm>
-          <a:prstGeom prst="rect">
-            <a:avLst/>
-          </a:prstGeom>
-          <a:noFill/>
-        </p:spPr>
-        <p:txBody>
-          <a:bodyPr wrap="square">
-            <a:spAutoFit/>
-          </a:bodyPr>
-          <a:lstStyle/>
-          <a:p>
-            <a:r>
-              <a:rPr sz="1200" b="1">
-                <a:solidFill>
-                  <a:srgbClr val="B4553C"/>
-                </a:solidFill>
-              </a:rPr>
-              <a:t>INTERFACE</a:t>
-            </a:r>
-          </a:p>
-        </p:txBody>
-      </p:sp>
-      <p:sp>
-        <p:nvSpPr>
-          <p:cNvPr id="11" name="TextBox 10"/>
-          <p:cNvSpPr txBox="1"/>
-          <p:nvPr/>
-        </p:nvSpPr>
-        <p:spPr>
-          <a:xfrm>
-            <a:off x="8092440" y="6035040"/>
-            <a:ext cx="3200400" cy="548640"/>
-          </a:xfrm>
-          <a:prstGeom prst="rect">
-            <a:avLst/>
-          </a:prstGeom>
-          <a:noFill/>
-        </p:spPr>
-        <p:txBody>
-          <a:bodyPr wrap="square">
-            <a:spAutoFit/>
-          </a:bodyPr>
-          <a:lstStyle/>
-          <a:p>
-            <a:r>
-              <a:rPr sz="1350" b="1">
+              </a:defRPr>
+            </a:pPr>
+            <a:r>
+              <a:rPr sz="1500" b="1">
                 <a:solidFill>
                   <a:srgbClr val="1F3355"/>
                 </a:solidFill>
               </a:rPr>
-              <a:t>2.6x worse in emergent narrative.</a:t>
-            </a:r>
-          </a:p>
-          <a:p>
-            <a:r>
-              <a:rPr sz="1350" b="1">
-                <a:solidFill>
-                  <a:srgbClr val="1F3355"/>
-                </a:solidFill>
-              </a:rPr>
-              <a:t>Depth brings opacity.</a:t>
-            </a:r>
-          </a:p>
-        </p:txBody>
-      </p:sp>
-      <p:sp>
-        <p:nvSpPr>
-          <p:cNvPr id="12" name="TextBox 11"/>
-          <p:cNvSpPr txBox="1"/>
-          <p:nvPr/>
-        </p:nvSpPr>
-        <p:spPr>
-          <a:xfrm>
-            <a:off x="11082528" y="6419088"/>
-            <a:ext cx="649224" cy="228600"/>
-          </a:xfrm>
-          <a:prstGeom prst="rect">
-            <a:avLst/>
-          </a:prstGeom>
-          <a:noFill/>
-        </p:spPr>
-        <p:txBody>
-          <a:bodyPr wrap="square">
-            <a:spAutoFit/>
-          </a:bodyPr>
-          <a:lstStyle/>
-          <a:p>
+              <a:t>Thirty rows, and the second reader is an AI, not a second analyst. Read it as a rough ceiling, not as validation.</a:t>
+            </a:r>
+          </a:p>
+        </p:txBody>
+      </p:sp>
+      <p:sp>
+        <p:nvSpPr>
+          <p:cNvPr id="14" name="">
+            <a:extLst xmlns:a="http://schemas.openxmlformats.org/drawingml/2006/main">
+              <a:ext uri="{FF2B5EF4-FFF2-40B4-BE49-F238E27FC236}">
+                <a16:creationId xmlns:a16="http://schemas.microsoft.com/office/drawing/2014/main" id="{696E1F14-CA5F-472D-A2BC-1FDAF574D7FE}"/>
+              </a:ext>
+            </a:extLst>
+          </p:cNvPr>
+          <p:cNvSpPr>
+            <a:spLocks xmlns:a="http://schemas.openxmlformats.org/drawingml/2006/main" noGrp="1"/>
+          </p:cNvSpPr>
+          <p:nvPr/>
+        </p:nvSpPr>
+        <p:spPr>
+          <a:xfrm xmlns:a="http://schemas.openxmlformats.org/drawingml/2006/main">
+            <a:off x="11087100" y="6419850"/>
+            <a:ext cx="647700" cy="190500"/>
+          </a:xfrm>
+          <a:prstGeom xmlns:a="http://schemas.openxmlformats.org/drawingml/2006/main" prst="rect">
+            <a:avLst/>
+          </a:prstGeom>
+          <a:noFill xmlns:a="http://schemas.openxmlformats.org/drawingml/2006/main"/>
+          <a:ln xmlns:a="http://schemas.openxmlformats.org/drawingml/2006/main" w="0">
+            <a:noFill/>
+            <a:prstDash val="solid"/>
+          </a:ln>
+        </p:spPr>
+        <p:txBody>
+          <a:bodyPr xmlns:a="http://schemas.openxmlformats.org/drawingml/2006/main" anchor="t"/>
+          <a:lstStyle xmlns:a="http://schemas.openxmlformats.org/drawingml/2006/main"/>
+          <a:p xmlns:a="http://schemas.openxmlformats.org/drawingml/2006/main">
+            <a:pPr algn="r">
+              <a:defRPr sz="900" b="1">
+                <a:solidFill>
+                  <a:srgbClr val="2E6F9E"/>
+                </a:solidFill>
+              </a:defRPr>
+            </a:pPr>
             <a:r>
               <a:rPr sz="900" b="1">
                 <a:solidFill>
                   <a:srgbClr val="2E6F9E"/>
                 </a:solidFill>
               </a:rPr>
-              <a:t>09</a:t>
+              <a:t>11</a:t>
             </a:r>
           </a:p>
         </p:txBody>
       </p:sp>
     </p:spTree>
+    <p:extLst>
+      <p:ext uri="{BB962C8B-B14F-4D97-AF65-F5344CB8AC3E}">
+        <p14:creationId xmlns:p14="http://schemas.microsoft.com/office/powerpoint/2010/main" val="882741739"/>
+      </p:ext>
+    </p:extLst>
   </p:cSld>
-  <p:clrMapOvr>
-    <a:masterClrMapping/>
-  </p:clrMapOvr>
 </p:sld>
 </file>
 
@@ -9190,7 +9516,7 @@
                   <a:srgbClr val="1F3355"/>
                 </a:solidFill>
               </a:rPr>
-              <a:t>• The rule is rejected as a way of measuring meaning.</a:t>
+              <a:t>• This rule is rejected as a way of measuring meaning.</a:t>
             </a:r>
           </a:p>
           <a:p xmlns:a="http://schemas.openxmlformats.org/drawingml/2006/main">
@@ -9207,7 +9533,7 @@
                   <a:srgbClr val="1F3355"/>
                 </a:solidFill>
               </a:rPr>
-              <a:t>• Per-game rates show where keywords fired, not what players meant.</a:t>
+              <a:t>• Its per-game rates show where keywords fired, not what players meant.</a:t>
             </a:r>
           </a:p>
           <a:p xmlns:a="http://schemas.openxmlformats.org/drawingml/2006/main">
@@ -9224,7 +9550,7 @@
                   <a:srgbClr val="1F3355"/>
                 </a:solidFill>
               </a:rPr>
-              <a:t>• No positioning conclusion survives version 1.</a:t>
+              <a:t>• No conclusion about generated content survives version 1.</a:t>
             </a:r>
           </a:p>
         </p:txBody>
@@ -9290,720 +9616,394 @@
 </file>
 
 <file path=ppt/slides/slide9.xml><?xml version="1.0" encoding="utf-8"?>
-<p:sld xmlns:p="http://schemas.openxmlformats.org/presentationml/2006/main">
+<p:sld xmlns:a="http://schemas.openxmlformats.org/drawingml/2006/main" xmlns:p="http://schemas.openxmlformats.org/presentationml/2006/main" xmlns:r="http://schemas.openxmlformats.org/officeDocument/2006/relationships">
   <p:cSld>
-    <p:bg>
-      <p:bgPr>
-        <a:solidFill xmlns:a="http://schemas.openxmlformats.org/drawingml/2006/main">
-          <a:srgbClr val="FFFFFF"/>
-        </a:solidFill>
-      </p:bgPr>
-    </p:bg>
     <p:spTree>
       <p:nvGrpSpPr>
         <p:cNvPr id="1" name=""/>
         <p:cNvGrpSpPr/>
         <p:nvPr/>
       </p:nvGrpSpPr>
-      <p:grpSpPr>
-        <a:xfrm xmlns:a="http://schemas.openxmlformats.org/drawingml/2006/main"/>
-      </p:grpSpPr>
-      <p:sp>
-        <p:nvSpPr>
-          <p:cNvPr id="15" name="">
-            <a:extLst xmlns:a="http://schemas.openxmlformats.org/drawingml/2006/main">
-              <a:ext uri="{FF2B5EF4-FFF2-40B4-BE49-F238E27FC236}">
-                <a16:creationId xmlns:a16="http://schemas.microsoft.com/office/drawing/2014/main" id="{B908D76C-BEF7-4CD9-B54E-73A4E0E590E5}"/>
-              </a:ext>
-            </a:extLst>
-          </p:cNvPr>
-          <p:cNvSpPr>
-            <a:spLocks xmlns:a="http://schemas.openxmlformats.org/drawingml/2006/main" noGrp="1"/>
-          </p:cNvSpPr>
-          <p:nvPr/>
-        </p:nvSpPr>
-        <p:spPr>
-          <a:xfrm xmlns:a="http://schemas.openxmlformats.org/drawingml/2006/main">
-            <a:off x="685800" y="323850"/>
-            <a:ext cx="2857500" cy="228600"/>
-          </a:xfrm>
-          <a:prstGeom xmlns:a="http://schemas.openxmlformats.org/drawingml/2006/main" prst="rect">
-            <a:avLst/>
-          </a:prstGeom>
-          <a:noFill xmlns:a="http://schemas.openxmlformats.org/drawingml/2006/main"/>
-          <a:ln xmlns:a="http://schemas.openxmlformats.org/drawingml/2006/main" w="0">
-            <a:noFill/>
-            <a:prstDash val="solid"/>
-          </a:ln>
-        </p:spPr>
-        <p:txBody>
-          <a:bodyPr xmlns:a="http://schemas.openxmlformats.org/drawingml/2006/main" anchor="t"/>
-          <a:lstStyle xmlns:a="http://schemas.openxmlformats.org/drawingml/2006/main"/>
-          <a:p xmlns:a="http://schemas.openxmlformats.org/drawingml/2006/main">
-            <a:pPr algn="l">
-              <a:defRPr sz="1050" b="1">
+      <p:grpSpPr/>
+      <p:sp>
+        <p:nvSpPr>
+          <p:cNvPr id="2" name="TextBox 1"/>
+          <p:cNvSpPr txBox="1"/>
+          <p:nvPr/>
+        </p:nvSpPr>
+        <p:spPr>
+          <a:xfrm>
+            <a:off x="685800" y="320040"/>
+            <a:ext cx="2852928" cy="228600"/>
+          </a:xfrm>
+          <a:prstGeom prst="rect">
+            <a:avLst/>
+          </a:prstGeom>
+          <a:noFill/>
+        </p:spPr>
+        <p:txBody>
+          <a:bodyPr wrap="square">
+            <a:spAutoFit/>
+          </a:bodyPr>
+          <a:lstStyle/>
+          <a:p>
+            <a:r>
+              <a:rPr sz="1050" b="1">
                 <a:solidFill>
                   <a:srgbClr val="B4553C"/>
                 </a:solidFill>
-              </a:defRPr>
-            </a:pPr>
-            <a:r>
-              <a:rPr sz="1050" b="1">
+              </a:rPr>
+              <a:t>WHAT SURVIVED</a:t>
+            </a:r>
+          </a:p>
+        </p:txBody>
+      </p:sp>
+      <p:sp>
+        <p:nvSpPr>
+          <p:cNvPr id="3" name="TextBox 2"/>
+          <p:cNvSpPr txBox="1"/>
+          <p:nvPr/>
+        </p:nvSpPr>
+        <p:spPr>
+          <a:xfrm>
+            <a:off x="685800" y="566928"/>
+            <a:ext cx="10817352" cy="548640"/>
+          </a:xfrm>
+          <a:prstGeom prst="rect">
+            <a:avLst/>
+          </a:prstGeom>
+          <a:noFill/>
+        </p:spPr>
+        <p:txBody>
+          <a:bodyPr wrap="square">
+            <a:spAutoFit/>
+          </a:bodyPr>
+          <a:lstStyle/>
+          <a:p>
+            <a:r>
+              <a:rPr sz="2850" b="1">
+                <a:solidFill>
+                  <a:srgbClr val="1F3355"/>
+                </a:solidFill>
+              </a:rPr>
+              <a:t>Three categories held up, and they name the problem</a:t>
+            </a:r>
+          </a:p>
+        </p:txBody>
+      </p:sp>
+      <p:sp>
+        <p:nvSpPr>
+          <p:cNvPr id="4" name="TextBox 3"/>
+          <p:cNvSpPr txBox="1"/>
+          <p:nvPr/>
+        </p:nvSpPr>
+        <p:spPr>
+          <a:xfrm>
+            <a:off x="685800" y="1133856"/>
+            <a:ext cx="10817352" cy="365760"/>
+          </a:xfrm>
+          <a:prstGeom prst="rect">
+            <a:avLst/>
+          </a:prstGeom>
+          <a:noFill/>
+        </p:spPr>
+        <p:txBody>
+          <a:bodyPr wrap="square">
+            <a:spAutoFit/>
+          </a:bodyPr>
+          <a:lstStyle/>
+          <a:p>
+            <a:r>
+              <a:rPr sz="1500" b="0">
+                <a:solidFill>
+                  <a:srgbClr val="2E6F9E"/>
+                </a:solidFill>
+              </a:rPr>
+              <a:t>Only bugs, grind and interface cleared validation. Unit is the game; rates understate, so read this as a ranking rather than levels.</a:t>
+            </a:r>
+          </a:p>
+        </p:txBody>
+      </p:sp>
+      <p:pic>
+        <p:nvPicPr>
+          <p:cNvPr id="5" name="Picture 4" descr="05b_supported_finding_bare.png"/>
+          <p:cNvPicPr>
+            <a:picLocks noChangeAspect="1"/>
+          </p:cNvPicPr>
+          <p:nvPr/>
+        </p:nvPicPr>
+        <p:blipFill>
+          <a:blip r:embed="rId2"/>
+          <a:stretch>
+            <a:fillRect/>
+          </a:stretch>
+        </p:blipFill>
+        <p:spPr>
+          <a:xfrm>
+            <a:off x="868680" y="1645920"/>
+            <a:ext cx="10469880" cy="4187952"/>
+          </a:xfrm>
+          <a:prstGeom prst="rect">
+            <a:avLst/>
+          </a:prstGeom>
+        </p:spPr>
+      </p:pic>
+      <p:sp>
+        <p:nvSpPr>
+          <p:cNvPr id="6" name="TextBox 5"/>
+          <p:cNvSpPr txBox="1"/>
+          <p:nvPr/>
+        </p:nvSpPr>
+        <p:spPr>
+          <a:xfrm>
+            <a:off x="868680" y="5760720"/>
+            <a:ext cx="3108960" cy="256032"/>
+          </a:xfrm>
+          <a:prstGeom prst="rect">
+            <a:avLst/>
+          </a:prstGeom>
+          <a:noFill/>
+        </p:spPr>
+        <p:txBody>
+          <a:bodyPr wrap="square">
+            <a:spAutoFit/>
+          </a:bodyPr>
+          <a:lstStyle/>
+          <a:p>
+            <a:r>
+              <a:rPr sz="1200" b="1">
+                <a:solidFill>
+                  <a:srgbClr val="2E6F9E"/>
+                </a:solidFill>
+              </a:rPr>
+              <a:t>BUGS</a:t>
+            </a:r>
+          </a:p>
+        </p:txBody>
+      </p:sp>
+      <p:sp>
+        <p:nvSpPr>
+          <p:cNvPr id="7" name="TextBox 6"/>
+          <p:cNvSpPr txBox="1"/>
+          <p:nvPr/>
+        </p:nvSpPr>
+        <p:spPr>
+          <a:xfrm>
+            <a:off x="868680" y="6035040"/>
+            <a:ext cx="3200400" cy="548640"/>
+          </a:xfrm>
+          <a:prstGeom prst="rect">
+            <a:avLst/>
+          </a:prstGeom>
+          <a:noFill/>
+        </p:spPr>
+        <p:txBody>
+          <a:bodyPr wrap="square">
+            <a:spAutoFit/>
+          </a:bodyPr>
+          <a:lstStyle/>
+          <a:p>
+            <a:r>
+              <a:rPr sz="1350" b="1">
+                <a:solidFill>
+                  <a:srgbClr val="1F3355"/>
+                </a:solidFill>
+              </a:rPr>
+              <a:t>Flat across all four shelves (1.2x).</a:t>
+            </a:r>
+          </a:p>
+          <a:p>
+            <a:r>
+              <a:rPr sz="1350" b="1">
+                <a:solidFill>
+                  <a:srgbClr val="1F3355"/>
+                </a:solidFill>
+              </a:rPr>
+              <a:t>The price of entry, not a lever.</a:t>
+            </a:r>
+          </a:p>
+        </p:txBody>
+      </p:sp>
+      <p:sp>
+        <p:nvSpPr>
+          <p:cNvPr id="8" name="TextBox 7"/>
+          <p:cNvSpPr txBox="1"/>
+          <p:nvPr/>
+        </p:nvSpPr>
+        <p:spPr>
+          <a:xfrm>
+            <a:off x="4480560" y="5760720"/>
+            <a:ext cx="3108960" cy="256032"/>
+          </a:xfrm>
+          <a:prstGeom prst="rect">
+            <a:avLst/>
+          </a:prstGeom>
+          <a:noFill/>
+        </p:spPr>
+        <p:txBody>
+          <a:bodyPr wrap="square">
+            <a:spAutoFit/>
+          </a:bodyPr>
+          <a:lstStyle/>
+          <a:p>
+            <a:r>
+              <a:rPr sz="1200" b="1">
                 <a:solidFill>
                   <a:srgbClr val="B4553C"/>
                 </a:solidFill>
               </a:rPr>
-              <a:t>WHY IT FAILED</a:t>
-            </a:r>
-          </a:p>
-        </p:txBody>
-      </p:sp>
-      <p:sp>
-        <p:nvSpPr>
-          <p:cNvPr id="2" name="">
-            <a:extLst xmlns:a="http://schemas.openxmlformats.org/drawingml/2006/main">
-              <a:ext uri="{FF2B5EF4-FFF2-40B4-BE49-F238E27FC236}">
-                <a16:creationId xmlns:a16="http://schemas.microsoft.com/office/drawing/2014/main" id="{A72C9EEB-E4F7-4573-950C-54D39204C468}"/>
-              </a:ext>
-            </a:extLst>
-          </p:cNvPr>
-          <p:cNvSpPr>
-            <a:spLocks xmlns:a="http://schemas.openxmlformats.org/drawingml/2006/main" noGrp="1"/>
-          </p:cNvSpPr>
-          <p:nvPr/>
-        </p:nvSpPr>
-        <p:spPr>
-          <a:xfrm xmlns:a="http://schemas.openxmlformats.org/drawingml/2006/main">
-            <a:off x="685800" y="571500"/>
-            <a:ext cx="10820400" cy="552450"/>
-          </a:xfrm>
-          <a:prstGeom xmlns:a="http://schemas.openxmlformats.org/drawingml/2006/main" prst="rect">
-            <a:avLst/>
-          </a:prstGeom>
-          <a:noFill xmlns:a="http://schemas.openxmlformats.org/drawingml/2006/main"/>
-          <a:ln xmlns:a="http://schemas.openxmlformats.org/drawingml/2006/main" w="0">
-            <a:noFill/>
-            <a:prstDash val="solid"/>
-          </a:ln>
-        </p:spPr>
-        <p:txBody>
-          <a:bodyPr xmlns:a="http://schemas.openxmlformats.org/drawingml/2006/main" anchor="t"/>
-          <a:lstStyle xmlns:a="http://schemas.openxmlformats.org/drawingml/2006/main"/>
-          <a:p xmlns:a="http://schemas.openxmlformats.org/drawingml/2006/main">
-            <a:pPr algn="l">
-              <a:defRPr sz="2850" b="1">
+              <a:t>GRIND</a:t>
+            </a:r>
+          </a:p>
+        </p:txBody>
+      </p:sp>
+      <p:sp>
+        <p:nvSpPr>
+          <p:cNvPr id="9" name="TextBox 8"/>
+          <p:cNvSpPr txBox="1"/>
+          <p:nvPr/>
+        </p:nvSpPr>
+        <p:spPr>
+          <a:xfrm>
+            <a:off x="4480560" y="6035040"/>
+            <a:ext cx="3200400" cy="548640"/>
+          </a:xfrm>
+          <a:prstGeom prst="rect">
+            <a:avLst/>
+          </a:prstGeom>
+          <a:noFill/>
+        </p:spPr>
+        <p:txBody>
+          <a:bodyPr wrap="square">
+            <a:spAutoFit/>
+          </a:bodyPr>
+          <a:lstStyle/>
+          <a:p>
+            <a:r>
+              <a:rPr sz="1350" b="1">
                 <a:solidFill>
                   <a:srgbClr val="1F3355"/>
                 </a:solidFill>
-              </a:defRPr>
-            </a:pPr>
-            <a:r>
-              <a:rPr sz="2850" b="1">
+              </a:rPr>
+              <a:t>3.0x worse in life sims (27% vs 9%).</a:t>
+            </a:r>
+          </a:p>
+        </p:txBody>
+      </p:sp>
+      <p:sp>
+        <p:nvSpPr>
+          <p:cNvPr id="10" name="TextBox 9"/>
+          <p:cNvSpPr txBox="1"/>
+          <p:nvPr/>
+        </p:nvSpPr>
+        <p:spPr>
+          <a:xfrm>
+            <a:off x="8092440" y="5760720"/>
+            <a:ext cx="3108960" cy="256032"/>
+          </a:xfrm>
+          <a:prstGeom prst="rect">
+            <a:avLst/>
+          </a:prstGeom>
+          <a:noFill/>
+        </p:spPr>
+        <p:txBody>
+          <a:bodyPr wrap="square">
+            <a:spAutoFit/>
+          </a:bodyPr>
+          <a:lstStyle/>
+          <a:p>
+            <a:r>
+              <a:rPr sz="1200" b="1">
+                <a:solidFill>
+                  <a:srgbClr val="B4553C"/>
+                </a:solidFill>
+              </a:rPr>
+              <a:t>INTERFACE</a:t>
+            </a:r>
+          </a:p>
+        </p:txBody>
+      </p:sp>
+      <p:sp>
+        <p:nvSpPr>
+          <p:cNvPr id="11" name="TextBox 10"/>
+          <p:cNvSpPr txBox="1"/>
+          <p:nvPr/>
+        </p:nvSpPr>
+        <p:spPr>
+          <a:xfrm>
+            <a:off x="8092440" y="6035040"/>
+            <a:ext cx="3200400" cy="548640"/>
+          </a:xfrm>
+          <a:prstGeom prst="rect">
+            <a:avLst/>
+          </a:prstGeom>
+          <a:noFill/>
+        </p:spPr>
+        <p:txBody>
+          <a:bodyPr wrap="square">
+            <a:spAutoFit/>
+          </a:bodyPr>
+          <a:lstStyle/>
+          <a:p>
+            <a:r>
+              <a:rPr sz="1350" b="1">
                 <a:solidFill>
                   <a:srgbClr val="1F3355"/>
                 </a:solidFill>
               </a:rPr>
-              <a:t>The rules matched subjects, and missed how people actually complain</a:t>
-            </a:r>
-          </a:p>
-        </p:txBody>
-      </p:sp>
-      <p:sp>
-        <p:nvSpPr>
-          <p:cNvPr id="3" name="">
-            <a:extLst xmlns:a="http://schemas.openxmlformats.org/drawingml/2006/main">
-              <a:ext uri="{FF2B5EF4-FFF2-40B4-BE49-F238E27FC236}">
-                <a16:creationId xmlns:a16="http://schemas.microsoft.com/office/drawing/2014/main" id="{63A9FB2E-3878-4307-8EC6-2FFEAB6F3218}"/>
-              </a:ext>
-            </a:extLst>
-          </p:cNvPr>
-          <p:cNvSpPr>
-            <a:spLocks xmlns:a="http://schemas.openxmlformats.org/drawingml/2006/main" noGrp="1"/>
-          </p:cNvSpPr>
-          <p:nvPr/>
-        </p:nvSpPr>
-        <p:spPr>
-          <a:xfrm xmlns:a="http://schemas.openxmlformats.org/drawingml/2006/main">
-            <a:off x="685800" y="1133475"/>
-            <a:ext cx="10820400" cy="342900"/>
-          </a:xfrm>
-          <a:prstGeom xmlns:a="http://schemas.openxmlformats.org/drawingml/2006/main" prst="rect">
-            <a:avLst/>
-          </a:prstGeom>
-          <a:noFill xmlns:a="http://schemas.openxmlformats.org/drawingml/2006/main"/>
-          <a:ln xmlns:a="http://schemas.openxmlformats.org/drawingml/2006/main" w="0">
-            <a:noFill/>
-            <a:prstDash val="solid"/>
-          </a:ln>
-        </p:spPr>
-        <p:txBody>
-          <a:bodyPr xmlns:a="http://schemas.openxmlformats.org/drawingml/2006/main" anchor="t"/>
-          <a:lstStyle xmlns:a="http://schemas.openxmlformats.org/drawingml/2006/main"/>
-          <a:p xmlns:a="http://schemas.openxmlformats.org/drawingml/2006/main">
-            <a:pPr algn="l">
-              <a:defRPr sz="1500" b="0">
+              <a:t>2.6x worse in emergent narrative.</a:t>
+            </a:r>
+          </a:p>
+          <a:p>
+            <a:r>
+              <a:rPr sz="1350" b="1">
+                <a:solidFill>
+                  <a:srgbClr val="1F3355"/>
+                </a:solidFill>
+              </a:rPr>
+              <a:t>Depth brings opacity.</a:t>
+            </a:r>
+          </a:p>
+        </p:txBody>
+      </p:sp>
+      <p:sp>
+        <p:nvSpPr>
+          <p:cNvPr id="12" name="TextBox 11"/>
+          <p:cNvSpPr txBox="1"/>
+          <p:nvPr/>
+        </p:nvSpPr>
+        <p:spPr>
+          <a:xfrm>
+            <a:off x="11082528" y="6419088"/>
+            <a:ext cx="649224" cy="228600"/>
+          </a:xfrm>
+          <a:prstGeom prst="rect">
+            <a:avLst/>
+          </a:prstGeom>
+          <a:noFill/>
+        </p:spPr>
+        <p:txBody>
+          <a:bodyPr wrap="square">
+            <a:spAutoFit/>
+          </a:bodyPr>
+          <a:lstStyle/>
+          <a:p>
+            <a:r>
+              <a:rPr sz="900" b="1">
                 <a:solidFill>
                   <a:srgbClr val="2E6F9E"/>
                 </a:solidFill>
-              </a:defRPr>
-            </a:pPr>
-            <a:r>
-              <a:rPr sz="1500" b="0">
-                <a:solidFill>
-                  <a:srgbClr val="2E6F9E"/>
-                </a:solidFill>
-              </a:rPr>
-              <a:t>Two separate failures. Only one of them can be fixed by writing better rules.</a:t>
-            </a:r>
-          </a:p>
-        </p:txBody>
-      </p:sp>
-      <p:sp>
-        <p:nvSpPr>
-          <p:cNvPr id="4" name="">
-            <a:extLst xmlns:a="http://schemas.openxmlformats.org/drawingml/2006/main">
-              <a:ext uri="{FF2B5EF4-FFF2-40B4-BE49-F238E27FC236}">
-                <a16:creationId xmlns:a16="http://schemas.microsoft.com/office/drawing/2014/main" id="{C20D7528-ABBF-41ED-B61C-11F143F7F575}"/>
-              </a:ext>
-            </a:extLst>
-          </p:cNvPr>
-          <p:cNvSpPr>
-            <a:spLocks xmlns:a="http://schemas.openxmlformats.org/drawingml/2006/main" noGrp="1"/>
-          </p:cNvSpPr>
-          <p:nvPr/>
-        </p:nvSpPr>
-        <p:spPr>
-          <a:xfrm xmlns:a="http://schemas.openxmlformats.org/drawingml/2006/main">
-            <a:off x="819150" y="2076450"/>
-            <a:ext cx="2952750" cy="857250"/>
-          </a:xfrm>
-          <a:prstGeom xmlns:a="http://schemas.openxmlformats.org/drawingml/2006/main" prst="rect">
-            <a:avLst/>
-          </a:prstGeom>
-          <a:noFill xmlns:a="http://schemas.openxmlformats.org/drawingml/2006/main"/>
-          <a:ln xmlns:a="http://schemas.openxmlformats.org/drawingml/2006/main" w="0">
-            <a:noFill/>
-            <a:prstDash val="solid"/>
-          </a:ln>
-        </p:spPr>
-        <p:txBody>
-          <a:bodyPr xmlns:a="http://schemas.openxmlformats.org/drawingml/2006/main" anchor="t"/>
-          <a:lstStyle xmlns:a="http://schemas.openxmlformats.org/drawingml/2006/main"/>
-          <a:p xmlns:a="http://schemas.openxmlformats.org/drawingml/2006/main">
-            <a:pPr algn="ctr">
-              <a:defRPr sz="4950" b="1">
-                <a:solidFill>
-                  <a:srgbClr val="2E6F9E"/>
-                </a:solidFill>
-              </a:defRPr>
-            </a:pPr>
-            <a:r>
-              <a:rPr sz="4950" b="1">
-                <a:solidFill>
-                  <a:srgbClr val="2E6F9E"/>
-                </a:solidFill>
-              </a:rPr>
-              <a:t>31 of 150</a:t>
-            </a:r>
-          </a:p>
-        </p:txBody>
-      </p:sp>
-      <p:sp>
-        <p:nvSpPr>
-          <p:cNvPr id="5" name="">
-            <a:extLst xmlns:a="http://schemas.openxmlformats.org/drawingml/2006/main">
-              <a:ext uri="{FF2B5EF4-FFF2-40B4-BE49-F238E27FC236}">
-                <a16:creationId xmlns:a16="http://schemas.microsoft.com/office/drawing/2014/main" id="{5FE5E172-5261-45C7-92E0-B6F858EAD73B}"/>
-              </a:ext>
-            </a:extLst>
-          </p:cNvPr>
-          <p:cNvSpPr>
-            <a:spLocks xmlns:a="http://schemas.openxmlformats.org/drawingml/2006/main" noGrp="1"/>
-          </p:cNvSpPr>
-          <p:nvPr/>
-        </p:nvSpPr>
-        <p:spPr>
-          <a:xfrm xmlns:a="http://schemas.openxmlformats.org/drawingml/2006/main">
-            <a:off x="819150" y="2952750"/>
-            <a:ext cx="2952750" cy="304800"/>
-          </a:xfrm>
-          <a:prstGeom xmlns:a="http://schemas.openxmlformats.org/drawingml/2006/main" prst="rect">
-            <a:avLst/>
-          </a:prstGeom>
-          <a:noFill xmlns:a="http://schemas.openxmlformats.org/drawingml/2006/main"/>
-          <a:ln xmlns:a="http://schemas.openxmlformats.org/drawingml/2006/main" w="0">
-            <a:noFill/>
-            <a:prstDash val="solid"/>
-          </a:ln>
-        </p:spPr>
-        <p:txBody>
-          <a:bodyPr xmlns:a="http://schemas.openxmlformats.org/drawingml/2006/main" anchor="t"/>
-          <a:lstStyle xmlns:a="http://schemas.openxmlformats.org/drawingml/2006/main"/>
-          <a:p xmlns:a="http://schemas.openxmlformats.org/drawingml/2006/main">
-            <a:pPr algn="ctr">
-              <a:defRPr sz="1425" b="1">
-                <a:solidFill>
-                  <a:srgbClr val="1F3355"/>
-                </a:solidFill>
-              </a:defRPr>
-            </a:pPr>
-            <a:r>
-              <a:rPr sz="1425" b="1">
-                <a:solidFill>
-                  <a:srgbClr val="1F3355"/>
-                </a:solidFill>
-              </a:rPr>
-              <a:t>reviews matched no rule at all</a:t>
-            </a:r>
-          </a:p>
-        </p:txBody>
-      </p:sp>
-      <p:sp>
-        <p:nvSpPr>
-          <p:cNvPr id="6" name="">
-            <a:extLst xmlns:a="http://schemas.openxmlformats.org/drawingml/2006/main">
-              <a:ext uri="{FF2B5EF4-FFF2-40B4-BE49-F238E27FC236}">
-                <a16:creationId xmlns:a16="http://schemas.microsoft.com/office/drawing/2014/main" id="{A99E4221-2938-40B6-A6E9-8F555E692B84}"/>
-              </a:ext>
-            </a:extLst>
-          </p:cNvPr>
-          <p:cNvSpPr>
-            <a:spLocks xmlns:a="http://schemas.openxmlformats.org/drawingml/2006/main" noGrp="1"/>
-          </p:cNvSpPr>
-          <p:nvPr/>
-        </p:nvSpPr>
-        <p:spPr>
-          <a:xfrm xmlns:a="http://schemas.openxmlformats.org/drawingml/2006/main">
-            <a:off x="4533900" y="2076450"/>
-            <a:ext cx="2952750" cy="857250"/>
-          </a:xfrm>
-          <a:prstGeom xmlns:a="http://schemas.openxmlformats.org/drawingml/2006/main" prst="rect">
-            <a:avLst/>
-          </a:prstGeom>
-          <a:noFill xmlns:a="http://schemas.openxmlformats.org/drawingml/2006/main"/>
-          <a:ln xmlns:a="http://schemas.openxmlformats.org/drawingml/2006/main" w="0">
-            <a:noFill/>
-            <a:prstDash val="solid"/>
-          </a:ln>
-        </p:spPr>
-        <p:txBody>
-          <a:bodyPr xmlns:a="http://schemas.openxmlformats.org/drawingml/2006/main" anchor="t"/>
-          <a:lstStyle xmlns:a="http://schemas.openxmlformats.org/drawingml/2006/main"/>
-          <a:p xmlns:a="http://schemas.openxmlformats.org/drawingml/2006/main">
-            <a:pPr algn="ctr">
-              <a:defRPr sz="4950" b="1">
-                <a:solidFill>
-                  <a:srgbClr val="B4553C"/>
-                </a:solidFill>
-              </a:defRPr>
-            </a:pPr>
-            <a:r>
-              <a:rPr sz="4950" b="1">
-                <a:solidFill>
-                  <a:srgbClr val="B4553C"/>
-                </a:solidFill>
-              </a:rPr>
-              <a:t>22</a:t>
-            </a:r>
-          </a:p>
-        </p:txBody>
-      </p:sp>
-      <p:sp>
-        <p:nvSpPr>
-          <p:cNvPr id="7" name="">
-            <a:extLst xmlns:a="http://schemas.openxmlformats.org/drawingml/2006/main">
-              <a:ext uri="{FF2B5EF4-FFF2-40B4-BE49-F238E27FC236}">
-                <a16:creationId xmlns:a16="http://schemas.microsoft.com/office/drawing/2014/main" id="{05AAF1A3-E58D-48CD-BADA-6572FEDB74BE}"/>
-              </a:ext>
-            </a:extLst>
-          </p:cNvPr>
-          <p:cNvSpPr>
-            <a:spLocks xmlns:a="http://schemas.openxmlformats.org/drawingml/2006/main" noGrp="1"/>
-          </p:cNvSpPr>
-          <p:nvPr/>
-        </p:nvSpPr>
-        <p:spPr>
-          <a:xfrm xmlns:a="http://schemas.openxmlformats.org/drawingml/2006/main">
-            <a:off x="4533900" y="2952750"/>
-            <a:ext cx="2952750" cy="304800"/>
-          </a:xfrm>
-          <a:prstGeom xmlns:a="http://schemas.openxmlformats.org/drawingml/2006/main" prst="rect">
-            <a:avLst/>
-          </a:prstGeom>
-          <a:noFill xmlns:a="http://schemas.openxmlformats.org/drawingml/2006/main"/>
-          <a:ln xmlns:a="http://schemas.openxmlformats.org/drawingml/2006/main" w="0">
-            <a:noFill/>
-            <a:prstDash val="solid"/>
-          </a:ln>
-        </p:spPr>
-        <p:txBody>
-          <a:bodyPr xmlns:a="http://schemas.openxmlformats.org/drawingml/2006/main" anchor="t"/>
-          <a:lstStyle xmlns:a="http://schemas.openxmlformats.org/drawingml/2006/main"/>
-          <a:p xmlns:a="http://schemas.openxmlformats.org/drawingml/2006/main">
-            <a:pPr algn="ctr">
-              <a:defRPr sz="1425" b="1">
-                <a:solidFill>
-                  <a:srgbClr val="1F3355"/>
-                </a:solidFill>
-              </a:defRPr>
-            </a:pPr>
-            <a:r>
-              <a:rPr sz="1425" b="1">
-                <a:solidFill>
-                  <a:srgbClr val="1F3355"/>
-                </a:solidFill>
-              </a:rPr>
-              <a:t>patterns never once fired correctly</a:t>
-            </a:r>
-          </a:p>
-        </p:txBody>
-      </p:sp>
-      <p:sp>
-        <p:nvSpPr>
-          <p:cNvPr id="8" name="">
-            <a:extLst xmlns:a="http://schemas.openxmlformats.org/drawingml/2006/main">
-              <a:ext uri="{FF2B5EF4-FFF2-40B4-BE49-F238E27FC236}">
-                <a16:creationId xmlns:a16="http://schemas.microsoft.com/office/drawing/2014/main" id="{3BCAD4EE-516A-4E45-9C64-CB3686974C7A}"/>
-              </a:ext>
-            </a:extLst>
-          </p:cNvPr>
-          <p:cNvSpPr>
-            <a:spLocks xmlns:a="http://schemas.openxmlformats.org/drawingml/2006/main" noGrp="1"/>
-          </p:cNvSpPr>
-          <p:nvPr/>
-        </p:nvSpPr>
-        <p:spPr>
-          <a:xfrm xmlns:a="http://schemas.openxmlformats.org/drawingml/2006/main">
-            <a:off x="8248650" y="2076450"/>
-            <a:ext cx="2952750" cy="857250"/>
-          </a:xfrm>
-          <a:prstGeom xmlns:a="http://schemas.openxmlformats.org/drawingml/2006/main" prst="rect">
-            <a:avLst/>
-          </a:prstGeom>
-          <a:noFill xmlns:a="http://schemas.openxmlformats.org/drawingml/2006/main"/>
-          <a:ln xmlns:a="http://schemas.openxmlformats.org/drawingml/2006/main" w="0">
-            <a:noFill/>
-            <a:prstDash val="solid"/>
-          </a:ln>
-        </p:spPr>
-        <p:txBody>
-          <a:bodyPr xmlns:a="http://schemas.openxmlformats.org/drawingml/2006/main" anchor="t"/>
-          <a:lstStyle xmlns:a="http://schemas.openxmlformats.org/drawingml/2006/main"/>
-          <a:p xmlns:a="http://schemas.openxmlformats.org/drawingml/2006/main">
-            <a:pPr algn="ctr">
-              <a:defRPr sz="4950" b="1">
-                <a:solidFill>
-                  <a:srgbClr val="B4553C"/>
-                </a:solidFill>
-              </a:defRPr>
-            </a:pPr>
-            <a:r>
-              <a:rPr sz="4950" b="1">
-                <a:solidFill>
-                  <a:srgbClr val="B4553C"/>
-                </a:solidFill>
-              </a:rPr>
-              <a:t>32 of 44</a:t>
-            </a:r>
-          </a:p>
-        </p:txBody>
-      </p:sp>
-      <p:sp>
-        <p:nvSpPr>
-          <p:cNvPr id="9" name="">
-            <a:extLst xmlns:a="http://schemas.openxmlformats.org/drawingml/2006/main">
-              <a:ext uri="{FF2B5EF4-FFF2-40B4-BE49-F238E27FC236}">
-                <a16:creationId xmlns:a16="http://schemas.microsoft.com/office/drawing/2014/main" id="{7FB059CE-04A7-4F8A-B226-7D805B128EEE}"/>
-              </a:ext>
-            </a:extLst>
-          </p:cNvPr>
-          <p:cNvSpPr>
-            <a:spLocks xmlns:a="http://schemas.openxmlformats.org/drawingml/2006/main" noGrp="1"/>
-          </p:cNvSpPr>
-          <p:nvPr/>
-        </p:nvSpPr>
-        <p:spPr>
-          <a:xfrm xmlns:a="http://schemas.openxmlformats.org/drawingml/2006/main">
-            <a:off x="8248650" y="2952750"/>
-            <a:ext cx="2952750" cy="304800"/>
-          </a:xfrm>
-          <a:prstGeom xmlns:a="http://schemas.openxmlformats.org/drawingml/2006/main" prst="rect">
-            <a:avLst/>
-          </a:prstGeom>
-          <a:noFill xmlns:a="http://schemas.openxmlformats.org/drawingml/2006/main"/>
-          <a:ln xmlns:a="http://schemas.openxmlformats.org/drawingml/2006/main" w="0">
-            <a:noFill/>
-            <a:prstDash val="solid"/>
-          </a:ln>
-        </p:spPr>
-        <p:txBody>
-          <a:bodyPr xmlns:a="http://schemas.openxmlformats.org/drawingml/2006/main" anchor="t"/>
-          <a:lstStyle xmlns:a="http://schemas.openxmlformats.org/drawingml/2006/main"/>
-          <a:p xmlns:a="http://schemas.openxmlformats.org/drawingml/2006/main">
-            <a:pPr algn="ctr">
-              <a:defRPr sz="1425" b="1">
-                <a:solidFill>
-                  <a:srgbClr val="1F3355"/>
-                </a:solidFill>
-              </a:defRPr>
-            </a:pPr>
-            <a:r>
-              <a:rPr sz="1425" b="1">
-                <a:solidFill>
-                  <a:srgbClr val="1F3355"/>
-                </a:solidFill>
-              </a:rPr>
-              <a:t>depth complaints the rules missed</a:t>
-            </a:r>
-          </a:p>
-        </p:txBody>
-      </p:sp>
-      <p:sp>
-        <p:nvSpPr>
-          <p:cNvPr id="10" name="">
-            <a:extLst xmlns:a="http://schemas.openxmlformats.org/drawingml/2006/main">
-              <a:ext uri="{FF2B5EF4-FFF2-40B4-BE49-F238E27FC236}">
-                <a16:creationId xmlns:a16="http://schemas.microsoft.com/office/drawing/2014/main" id="{7F996775-9E23-44FA-99C8-ACD9FFFC59F2}"/>
-              </a:ext>
-            </a:extLst>
-          </p:cNvPr>
-          <p:cNvSpPr>
-            <a:spLocks xmlns:a="http://schemas.openxmlformats.org/drawingml/2006/main" noGrp="1"/>
-          </p:cNvSpPr>
-          <p:nvPr/>
-        </p:nvSpPr>
-        <p:spPr>
-          <a:xfrm xmlns:a="http://schemas.openxmlformats.org/drawingml/2006/main">
-            <a:off x="838200" y="3886200"/>
-            <a:ext cx="10382250" cy="1257300"/>
-          </a:xfrm>
-          <a:prstGeom xmlns:a="http://schemas.openxmlformats.org/drawingml/2006/main" prst="roundRect">
-            <a:avLst>
-              <a:gd name="adj" fmla="val 9091"/>
-            </a:avLst>
-          </a:prstGeom>
-          <a:solidFill xmlns:a="http://schemas.openxmlformats.org/drawingml/2006/main">
-            <a:srgbClr val="F4E3DD"/>
-          </a:solidFill>
-          <a:ln xmlns:a="http://schemas.openxmlformats.org/drawingml/2006/main" w="9525">
-            <a:solidFill>
-              <a:srgbClr val="F4E3DD"/>
-            </a:solidFill>
-            <a:prstDash val="solid"/>
-          </a:ln>
-        </p:spPr>
-        <p:txBody xmlns:a="http://schemas.openxmlformats.org/drawingml/2006/main">
-          <a:bodyPr/>
-          <a:p/>
-        </p:txBody>
-      </p:sp>
-      <p:sp>
-        <p:nvSpPr>
-          <p:cNvPr id="11" name="">
-            <a:extLst xmlns:a="http://schemas.openxmlformats.org/drawingml/2006/main">
-              <a:ext uri="{FF2B5EF4-FFF2-40B4-BE49-F238E27FC236}">
-                <a16:creationId xmlns:a16="http://schemas.microsoft.com/office/drawing/2014/main" id="{E80D3F1D-D08F-4DAF-89C3-3052BBCAE28B}"/>
-              </a:ext>
-            </a:extLst>
-          </p:cNvPr>
-          <p:cNvSpPr>
-            <a:spLocks xmlns:a="http://schemas.openxmlformats.org/drawingml/2006/main" noGrp="1"/>
-          </p:cNvSpPr>
-          <p:nvPr/>
-        </p:nvSpPr>
-        <p:spPr>
-          <a:xfrm xmlns:a="http://schemas.openxmlformats.org/drawingml/2006/main">
-            <a:off x="1123950" y="4171950"/>
-            <a:ext cx="2571750" cy="266700"/>
-          </a:xfrm>
-          <a:prstGeom xmlns:a="http://schemas.openxmlformats.org/drawingml/2006/main" prst="rect">
-            <a:avLst/>
-          </a:prstGeom>
-          <a:noFill xmlns:a="http://schemas.openxmlformats.org/drawingml/2006/main"/>
-          <a:ln xmlns:a="http://schemas.openxmlformats.org/drawingml/2006/main" w="0">
-            <a:noFill/>
-            <a:prstDash val="solid"/>
-          </a:ln>
-        </p:spPr>
-        <p:txBody>
-          <a:bodyPr xmlns:a="http://schemas.openxmlformats.org/drawingml/2006/main" anchor="t"/>
-          <a:lstStyle xmlns:a="http://schemas.openxmlformats.org/drawingml/2006/main"/>
-          <a:p xmlns:a="http://schemas.openxmlformats.org/drawingml/2006/main">
-            <a:pPr algn="l">
-              <a:defRPr sz="1350" b="1">
-                <a:solidFill>
-                  <a:srgbClr val="B4553C"/>
-                </a:solidFill>
-              </a:defRPr>
-            </a:pPr>
-            <a:r>
-              <a:rPr sz="1350" b="1">
-                <a:solidFill>
-                  <a:srgbClr val="B4553C"/>
-                </a:solidFill>
-              </a:rPr>
-              <a:t>The clearest example</a:t>
-            </a:r>
-          </a:p>
-        </p:txBody>
-      </p:sp>
-      <p:sp>
-        <p:nvSpPr>
-          <p:cNvPr id="12" name="">
-            <a:extLst xmlns:a="http://schemas.openxmlformats.org/drawingml/2006/main">
-              <a:ext uri="{FF2B5EF4-FFF2-40B4-BE49-F238E27FC236}">
-                <a16:creationId xmlns:a16="http://schemas.microsoft.com/office/drawing/2014/main" id="{266192CF-2380-44EA-8B6C-37E069BBAC36}"/>
-              </a:ext>
-            </a:extLst>
-          </p:cNvPr>
-          <p:cNvSpPr>
-            <a:spLocks xmlns:a="http://schemas.openxmlformats.org/drawingml/2006/main" noGrp="1"/>
-          </p:cNvSpPr>
-          <p:nvPr/>
-        </p:nvSpPr>
-        <p:spPr>
-          <a:xfrm xmlns:a="http://schemas.openxmlformats.org/drawingml/2006/main">
-            <a:off x="3848100" y="4086225"/>
-            <a:ext cx="7010400" cy="628650"/>
-          </a:xfrm>
-          <a:prstGeom xmlns:a="http://schemas.openxmlformats.org/drawingml/2006/main" prst="rect">
-            <a:avLst/>
-          </a:prstGeom>
-          <a:noFill xmlns:a="http://schemas.openxmlformats.org/drawingml/2006/main"/>
-          <a:ln xmlns:a="http://schemas.openxmlformats.org/drawingml/2006/main" w="0">
-            <a:noFill/>
-            <a:prstDash val="solid"/>
-          </a:ln>
-        </p:spPr>
-        <p:txBody>
-          <a:bodyPr xmlns:a="http://schemas.openxmlformats.org/drawingml/2006/main" anchor="t"/>
-          <a:lstStyle xmlns:a="http://schemas.openxmlformats.org/drawingml/2006/main"/>
-          <a:p xmlns:a="http://schemas.openxmlformats.org/drawingml/2006/main">
-            <a:pPr algn="l">
-              <a:defRPr sz="1725" b="1">
-                <a:solidFill>
-                  <a:srgbClr val="1F3355"/>
-                </a:solidFill>
-              </a:defRPr>
-            </a:pPr>
-            <a:r>
-              <a:rPr sz="1725" b="1">
-                <a:solidFill>
-                  <a:srgbClr val="1F3355"/>
-                </a:solidFill>
-              </a:rPr>
-              <a:t>The word “random” fired 11 times and I agreed with none of them. In these reviews it means “randomly generated”, not “unfair”.</a:t>
-            </a:r>
-          </a:p>
-        </p:txBody>
-      </p:sp>
-      <p:sp>
-        <p:nvSpPr>
-          <p:cNvPr id="13" name="">
-            <a:extLst xmlns:a="http://schemas.openxmlformats.org/drawingml/2006/main">
-              <a:ext uri="{FF2B5EF4-FFF2-40B4-BE49-F238E27FC236}">
-                <a16:creationId xmlns:a16="http://schemas.microsoft.com/office/drawing/2014/main" id="{82FF8426-CE28-4860-AFCD-FA2E667472EF}"/>
-              </a:ext>
-            </a:extLst>
-          </p:cNvPr>
-          <p:cNvSpPr>
-            <a:spLocks xmlns:a="http://schemas.openxmlformats.org/drawingml/2006/main" noGrp="1"/>
-          </p:cNvSpPr>
-          <p:nvPr/>
-        </p:nvSpPr>
-        <p:spPr>
-          <a:xfrm xmlns:a="http://schemas.openxmlformats.org/drawingml/2006/main">
-            <a:off x="1143000" y="5543550"/>
-            <a:ext cx="9906000" cy="457200"/>
-          </a:xfrm>
-          <a:prstGeom xmlns:a="http://schemas.openxmlformats.org/drawingml/2006/main" prst="rect">
-            <a:avLst/>
-          </a:prstGeom>
-          <a:noFill xmlns:a="http://schemas.openxmlformats.org/drawingml/2006/main"/>
-          <a:ln xmlns:a="http://schemas.openxmlformats.org/drawingml/2006/main" w="0">
-            <a:noFill/>
-            <a:prstDash val="solid"/>
-          </a:ln>
-        </p:spPr>
-        <p:txBody>
-          <a:bodyPr xmlns:a="http://schemas.openxmlformats.org/drawingml/2006/main" anchor="t"/>
-          <a:lstStyle xmlns:a="http://schemas.openxmlformats.org/drawingml/2006/main"/>
-          <a:p xmlns:a="http://schemas.openxmlformats.org/drawingml/2006/main">
-            <a:pPr algn="l">
-              <a:defRPr sz="1500" b="1">
-                <a:solidFill>
-                  <a:srgbClr val="1F3355"/>
-                </a:solidFill>
-              </a:defRPr>
-            </a:pPr>
-            <a:r>
-              <a:rPr sz="1500" b="1">
-                <a:solidFill>
-                  <a:srgbClr val="1F3355"/>
-                </a:solidFill>
-              </a:rPr>
-              <a:t>Matching the wrong word is fixable. Missing the words people actually use is not.</a:t>
-            </a:r>
-          </a:p>
-        </p:txBody>
-      </p:sp>
-      <p:sp>
-        <p:nvSpPr>
-          <p:cNvPr id="14" name="">
-            <a:extLst xmlns:a="http://schemas.openxmlformats.org/drawingml/2006/main">
-              <a:ext uri="{FF2B5EF4-FFF2-40B4-BE49-F238E27FC236}">
-                <a16:creationId xmlns:a16="http://schemas.microsoft.com/office/drawing/2014/main" id="{696E1F14-CA5F-472D-A2BC-1FDAF574D7FE}"/>
-              </a:ext>
-            </a:extLst>
-          </p:cNvPr>
-          <p:cNvSpPr>
-            <a:spLocks xmlns:a="http://schemas.openxmlformats.org/drawingml/2006/main" noGrp="1"/>
-          </p:cNvSpPr>
-          <p:nvPr/>
-        </p:nvSpPr>
-        <p:spPr>
-          <a:xfrm xmlns:a="http://schemas.openxmlformats.org/drawingml/2006/main">
-            <a:off x="11087100" y="6419850"/>
-            <a:ext cx="647700" cy="190500"/>
-          </a:xfrm>
-          <a:prstGeom xmlns:a="http://schemas.openxmlformats.org/drawingml/2006/main" prst="rect">
-            <a:avLst/>
-          </a:prstGeom>
-          <a:noFill xmlns:a="http://schemas.openxmlformats.org/drawingml/2006/main"/>
-          <a:ln xmlns:a="http://schemas.openxmlformats.org/drawingml/2006/main" w="0">
-            <a:noFill/>
-            <a:prstDash val="solid"/>
-          </a:ln>
-        </p:spPr>
-        <p:txBody>
-          <a:bodyPr xmlns:a="http://schemas.openxmlformats.org/drawingml/2006/main" anchor="t"/>
-          <a:lstStyle xmlns:a="http://schemas.openxmlformats.org/drawingml/2006/main"/>
-          <a:p xmlns:a="http://schemas.openxmlformats.org/drawingml/2006/main">
-            <a:pPr algn="r">
-              <a:defRPr sz="900" b="1">
-                <a:solidFill>
-                  <a:srgbClr val="2E6F9E"/>
-                </a:solidFill>
-              </a:defRPr>
-            </a:pPr>
-            <a:r>
-              <a:rPr sz="900" b="1">
-                <a:solidFill>
-                  <a:srgbClr val="2E6F9E"/>
-                </a:solidFill>
-              </a:rPr>
-              <a:t>10</a:t>
+              </a:rPr>
+              <a:t>09</a:t>
             </a:r>
           </a:p>
         </p:txBody>
       </p:sp>
     </p:spTree>
-    <p:extLst>
-      <p:ext uri="{BB962C8B-B14F-4D97-AF65-F5344CB8AC3E}">
-        <p14:creationId xmlns:p14="http://schemas.microsoft.com/office/powerpoint/2010/main" val="882741739"/>
-      </p:ext>
-    </p:extLst>
   </p:cSld>
+  <p:clrMapOvr>
+    <a:masterClrMapping/>
+  </p:clrMapOvr>
 </p:sld>
 </file>
 

</xml_diff>